<commit_message>
Update portfolio files, slides, and certificates
</commit_message>
<xml_diff>
--- a/project_files/hygiene_presentation.pptx
+++ b/project_files/hygiene_presentation.pptx
@@ -659,6 +659,18 @@
           <a:p>
             <a:r>
               <a:rPr lang="en-US"/>
+              <a:t>1.7.2013</a:t>
+            </a:r>
+          </a:p>
+          <a:p>
+            <a:r>
+              <a:rPr lang="en-US"/>
+              <a:t/>
+            </a:r>
+          </a:p>
+          <a:p>
+            <a:r>
+              <a:rPr lang="en-US"/>
               <a:t>Introduce yourself and the project: a school-based hygiene and infection prevention programme, prepared as part of my DAAD EPOS application for a Master of Public Health.</a:t>
             </a:r>
           </a:p>
@@ -666,6 +678,18 @@
             <a:r>
               <a:rPr lang="en-US"/>
               <a:t>1</a:t>
+            </a:r>
+          </a:p>
+          <a:p>
+            <a:r>
+              <a:rPr lang="en-US"/>
+              <a:t/>
+            </a:r>
+          </a:p>
+          <a:p>
+            <a:r>
+              <a:rPr lang="en-US"/>
+              <a:t>‹#›</a:t>
             </a:r>
           </a:p>
           <a:p>
@@ -925,6 +949,18 @@
           <a:p>
             <a:r>
               <a:rPr lang="en-US"/>
+              <a:t>1.7.2013</a:t>
+            </a:r>
+          </a:p>
+          <a:p>
+            <a:r>
+              <a:rPr lang="en-US"/>
+              <a:t/>
+            </a:r>
+          </a:p>
+          <a:p>
+            <a:r>
+              <a:rPr lang="en-US"/>
               <a:t>Interactive methods keep children engaged and support retention. Teacher reminders after the session make the programme sustainable.</a:t>
             </a:r>
           </a:p>
@@ -932,6 +968,18 @@
             <a:r>
               <a:rPr lang="en-US"/>
               <a:t>10</a:t>
+            </a:r>
+          </a:p>
+          <a:p>
+            <a:r>
+              <a:rPr lang="en-US"/>
+              <a:t/>
+            </a:r>
+          </a:p>
+          <a:p>
+            <a:r>
+              <a:rPr lang="en-US"/>
+              <a:t>‹#›</a:t>
             </a:r>
           </a:p>
           <a:p>
@@ -1191,6 +1239,18 @@
           <a:p>
             <a:r>
               <a:rPr lang="en-US"/>
+              <a:t>1.7.2013</a:t>
+            </a:r>
+          </a:p>
+          <a:p>
+            <a:r>
+              <a:rPr lang="en-US"/>
+              <a:t/>
+            </a:r>
+          </a:p>
+          <a:p>
+            <a:r>
+              <a:rPr lang="en-US"/>
               <a:t>Examples of the materials and activities used during the January–February 2026 visits to the participating government and private schools: posters, activity corners and craft work that make germs visible for young children.</a:t>
             </a:r>
           </a:p>
@@ -1198,6 +1258,18 @@
             <a:r>
               <a:rPr lang="en-US"/>
               <a:t>11</a:t>
+            </a:r>
+          </a:p>
+          <a:p>
+            <a:r>
+              <a:rPr lang="en-US"/>
+              <a:t/>
+            </a:r>
+          </a:p>
+          <a:p>
+            <a:r>
+              <a:rPr lang="en-US"/>
+              <a:t>‹#›</a:t>
             </a:r>
           </a:p>
           <a:p>
@@ -1457,6 +1529,18 @@
           <a:p>
             <a:r>
               <a:rPr lang="en-US"/>
+              <a:t>1.7.2013</a:t>
+            </a:r>
+          </a:p>
+          <a:p>
+            <a:r>
+              <a:rPr lang="en-US"/>
+              <a:t/>
+            </a:r>
+          </a:p>
+          <a:p>
+            <a:r>
+              <a:rPr lang="en-US"/>
               <a:t>The same six phases are carried out in all five schools, so results are comparable. Week 1 starts on 1 January 2026, and visits are staggered school by school, so phases 2 to 4 run inside each visit. Baseline and follow-up use the same questionnaire and checklist.</a:t>
             </a:r>
           </a:p>
@@ -1464,6 +1548,18 @@
             <a:r>
               <a:rPr lang="en-US"/>
               <a:t>12</a:t>
+            </a:r>
+          </a:p>
+          <a:p>
+            <a:r>
+              <a:rPr lang="en-US"/>
+              <a:t/>
+            </a:r>
+          </a:p>
+          <a:p>
+            <a:r>
+              <a:rPr lang="en-US"/>
+              <a:t>‹#›</a:t>
             </a:r>
           </a:p>
           <a:p>
@@ -1723,6 +1819,18 @@
           <a:p>
             <a:r>
               <a:rPr lang="en-US"/>
+              <a:t>1.7.2013</a:t>
+            </a:r>
+          </a:p>
+          <a:p>
+            <a:r>
+              <a:rPr lang="en-US"/>
+              <a:t/>
+            </a:r>
+          </a:p>
+          <a:p>
+            <a:r>
+              <a:rPr lang="en-US"/>
               <a:t>Working with minors requires clear safeguards. These principles follow good practice in public health research: permission, informed parents, data protection and child-safe conduct.</a:t>
             </a:r>
           </a:p>
@@ -1730,6 +1838,18 @@
             <a:r>
               <a:rPr lang="en-US"/>
               <a:t>13</a:t>
+            </a:r>
+          </a:p>
+          <a:p>
+            <a:r>
+              <a:rPr lang="en-US"/>
+              <a:t/>
+            </a:r>
+          </a:p>
+          <a:p>
+            <a:r>
+              <a:rPr lang="en-US"/>
+              <a:t>‹#›</a:t>
             </a:r>
           </a:p>
           <a:p>
@@ -1989,6 +2109,18 @@
           <a:p>
             <a:r>
               <a:rPr lang="en-US"/>
+              <a:t>1.7.2013</a:t>
+            </a:r>
+          </a:p>
+          <a:p>
+            <a:r>
+              <a:rPr lang="en-US"/>
+              <a:t/>
+            </a:r>
+          </a:p>
+          <a:p>
+            <a:r>
+              <a:rPr lang="en-US"/>
               <a:t>Outcomes move from knowledge to confidence to behaviour, and finally to sustainability through teachers.</a:t>
             </a:r>
           </a:p>
@@ -1996,6 +2128,18 @@
             <a:r>
               <a:rPr lang="en-US"/>
               <a:t>14</a:t>
+            </a:r>
+          </a:p>
+          <a:p>
+            <a:r>
+              <a:rPr lang="en-US"/>
+              <a:t/>
+            </a:r>
+          </a:p>
+          <a:p>
+            <a:r>
+              <a:rPr lang="en-US"/>
+              <a:t>‹#›</a:t>
             </a:r>
           </a:p>
           <a:p>
@@ -2255,6 +2399,18 @@
           <a:p>
             <a:r>
               <a:rPr lang="en-US"/>
+              <a:t>1.7.2013</a:t>
+            </a:r>
+          </a:p>
+          <a:p>
+            <a:r>
+              <a:rPr lang="en-US"/>
+              <a:t/>
+            </a:r>
+          </a:p>
+          <a:p>
+            <a:r>
+              <a:rPr lang="en-US"/>
               <a:t>The pre/post design allows a simple before-and-after comparison in each school and between government and private schools. Only aggregated, anonymous data are reported.</a:t>
             </a:r>
           </a:p>
@@ -2262,6 +2418,18 @@
             <a:r>
               <a:rPr lang="en-US"/>
               <a:t>15</a:t>
+            </a:r>
+          </a:p>
+          <a:p>
+            <a:r>
+              <a:rPr lang="en-US"/>
+              <a:t/>
+            </a:r>
+          </a:p>
+          <a:p>
+            <a:r>
+              <a:rPr lang="en-US"/>
+              <a:t>‹#›</a:t>
             </a:r>
           </a:p>
           <a:p>
@@ -2521,6 +2689,18 @@
           <a:p>
             <a:r>
               <a:rPr lang="en-US"/>
+              <a:t>1.7.2013</a:t>
+            </a:r>
+          </a:p>
+          <a:p>
+            <a:r>
+              <a:rPr lang="en-US"/>
+              <a:t/>
+            </a:r>
+          </a:p>
+          <a:p>
+            <a:r>
+              <a:rPr lang="en-US"/>
               <a:t>Educating children helps establish healthy habits that extend from school to home and the wider community. Long-term impact depends on sustained teacher involvement, adequate handwashing facilities, safe water and regular health education.</a:t>
             </a:r>
           </a:p>
@@ -2528,6 +2708,18 @@
             <a:r>
               <a:rPr lang="en-US"/>
               <a:t>16</a:t>
+            </a:r>
+          </a:p>
+          <a:p>
+            <a:r>
+              <a:rPr lang="en-US"/>
+              <a:t/>
+            </a:r>
+          </a:p>
+          <a:p>
+            <a:r>
+              <a:rPr lang="en-US"/>
+              <a:t>‹#›</a:t>
             </a:r>
           </a:p>
           <a:p>
@@ -2787,6 +2979,18 @@
           <a:p>
             <a:r>
               <a:rPr lang="en-US"/>
+              <a:t>1.7.2013</a:t>
+            </a:r>
+          </a:p>
+          <a:p>
+            <a:r>
+              <a:rPr lang="en-US"/>
+              <a:t/>
+            </a:r>
+          </a:p>
+          <a:p>
+            <a:r>
+              <a:rPr lang="en-US"/>
               <a:t>Online sources were last checked on the access date shown. The national reference is the Government of Pakistan National Sanitation Policy (2006), which covers sanitation and hygiene promotion, including in schools.</a:t>
             </a:r>
           </a:p>
@@ -2794,6 +2998,18 @@
             <a:r>
               <a:rPr lang="en-US"/>
               <a:t>17</a:t>
+            </a:r>
+          </a:p>
+          <a:p>
+            <a:r>
+              <a:rPr lang="en-US"/>
+              <a:t/>
+            </a:r>
+          </a:p>
+          <a:p>
+            <a:r>
+              <a:rPr lang="en-US"/>
+              <a:t>‹#›</a:t>
             </a:r>
           </a:p>
           <a:p>
@@ -3053,6 +3269,18 @@
           <a:p>
             <a:r>
               <a:rPr lang="en-US"/>
+              <a:t>1.7.2013</a:t>
+            </a:r>
+          </a:p>
+          <a:p>
+            <a:r>
+              <a:rPr lang="en-US"/>
+              <a:t/>
+            </a:r>
+          </a:p>
+          <a:p>
+            <a:r>
+              <a:rPr lang="en-US"/>
               <a:t>Thank the audience and invite questions.</a:t>
             </a:r>
           </a:p>
@@ -3060,6 +3288,18 @@
             <a:r>
               <a:rPr lang="en-US"/>
               <a:t>18</a:t>
+            </a:r>
+          </a:p>
+          <a:p>
+            <a:r>
+              <a:rPr lang="en-US"/>
+              <a:t/>
+            </a:r>
+          </a:p>
+          <a:p>
+            <a:r>
+              <a:rPr lang="en-US"/>
+              <a:t>‹#›</a:t>
             </a:r>
           </a:p>
           <a:p>
@@ -3319,6 +3559,18 @@
           <a:p>
             <a:r>
               <a:rPr lang="en-US"/>
+              <a:t>1.7.2013</a:t>
+            </a:r>
+          </a:p>
+          <a:p>
+            <a:r>
+              <a:rPr lang="en-US"/>
+              <a:t/>
+            </a:r>
+          </a:p>
+          <a:p>
+            <a:r>
+              <a:rPr lang="en-US"/>
               <a:t>The presentation follows the logic of a public health intervention: problem and setting, objectives and content, delivery, ethics, and finally outcomes and evaluation.</a:t>
             </a:r>
           </a:p>
@@ -3326,6 +3578,18 @@
             <a:r>
               <a:rPr lang="en-US"/>
               <a:t>2</a:t>
+            </a:r>
+          </a:p>
+          <a:p>
+            <a:r>
+              <a:rPr lang="en-US"/>
+              <a:t/>
+            </a:r>
+          </a:p>
+          <a:p>
+            <a:r>
+              <a:rPr lang="en-US"/>
+              <a:t>‹#›</a:t>
             </a:r>
           </a:p>
           <a:p>
@@ -3585,6 +3849,18 @@
           <a:p>
             <a:r>
               <a:rPr lang="en-US"/>
+              <a:t>1.7.2013</a:t>
+            </a:r>
+          </a:p>
+          <a:p>
+            <a:r>
+              <a:rPr lang="en-US"/>
+              <a:t/>
+            </a:r>
+          </a:p>
+          <a:p>
+            <a:r>
+              <a:rPr lang="en-US"/>
               <a:t>Poor personal hygiene contributes to respiratory infections, diarrhoeal illness, skin infections and other communicable diseases. Schools concentrate children in shared spaces, so they are both a risk setting and an ideal setting for prevention.</a:t>
             </a:r>
           </a:p>
@@ -3592,6 +3868,18 @@
             <a:r>
               <a:rPr lang="en-US"/>
               <a:t>3</a:t>
+            </a:r>
+          </a:p>
+          <a:p>
+            <a:r>
+              <a:rPr lang="en-US"/>
+              <a:t/>
+            </a:r>
+          </a:p>
+          <a:p>
+            <a:r>
+              <a:rPr lang="en-US"/>
+              <a:t>‹#›</a:t>
             </a:r>
           </a:p>
           <a:p>
@@ -3851,6 +4139,18 @@
           <a:p>
             <a:r>
               <a:rPr lang="en-US"/>
+              <a:t>1.7.2013</a:t>
+            </a:r>
+          </a:p>
+          <a:p>
+            <a:r>
+              <a:rPr lang="en-US"/>
+              <a:t/>
+            </a:r>
+          </a:p>
+          <a:p>
+            <a:r>
+              <a:rPr lang="en-US"/>
               <a:t>Each of the five schools (two government, three private) issued a No Objection Certificate for the visit. Including both government and private schools allows the programme to reach children in different settings and to compare baseline knowledge and hygiene facilities between the two sectors. Actual student numbers will come from the attendance registers, not estimates.</a:t>
             </a:r>
           </a:p>
@@ -3858,6 +4158,18 @@
             <a:r>
               <a:rPr lang="en-US"/>
               <a:t>4</a:t>
+            </a:r>
+          </a:p>
+          <a:p>
+            <a:r>
+              <a:rPr lang="en-US"/>
+              <a:t/>
+            </a:r>
+          </a:p>
+          <a:p>
+            <a:r>
+              <a:rPr lang="en-US"/>
+              <a:t>‹#›</a:t>
             </a:r>
           </a:p>
           <a:p>
@@ -4117,6 +4429,18 @@
           <a:p>
             <a:r>
               <a:rPr lang="en-US"/>
+              <a:t>1.7.2013</a:t>
+            </a:r>
+          </a:p>
+          <a:p>
+            <a:r>
+              <a:rPr lang="en-US"/>
+              <a:t/>
+            </a:r>
+          </a:p>
+          <a:p>
+            <a:r>
+              <a:rPr lang="en-US"/>
               <a:t>Objectives cover knowledge (why hygiene matters, how infections spread), skills (handwashing, cough etiquette) and behaviour (daily habits and sharing messages with families and classmates).</a:t>
             </a:r>
           </a:p>
@@ -4124,6 +4448,18 @@
             <a:r>
               <a:rPr lang="en-US"/>
               <a:t>5</a:t>
+            </a:r>
+          </a:p>
+          <a:p>
+            <a:r>
+              <a:rPr lang="en-US"/>
+              <a:t/>
+            </a:r>
+          </a:p>
+          <a:p>
+            <a:r>
+              <a:rPr lang="en-US"/>
+              <a:t>‹#›</a:t>
             </a:r>
           </a:p>
           <a:p>
@@ -4383,6 +4719,18 @@
           <a:p>
             <a:r>
               <a:rPr lang="en-US"/>
+              <a:t>1.7.2013</a:t>
+            </a:r>
+          </a:p>
+          <a:p>
+            <a:r>
+              <a:rPr lang="en-US"/>
+              <a:t/>
+            </a:r>
+          </a:p>
+          <a:p>
+            <a:r>
+              <a:rPr lang="en-US"/>
               <a:t>These messages are deliberately short so that children can remember and repeat them, and so that teachers can reuse them in daily reminders.</a:t>
             </a:r>
           </a:p>
@@ -4390,6 +4738,18 @@
             <a:r>
               <a:rPr lang="en-US"/>
               <a:t>6</a:t>
+            </a:r>
+          </a:p>
+          <a:p>
+            <a:r>
+              <a:rPr lang="en-US"/>
+              <a:t/>
+            </a:r>
+          </a:p>
+          <a:p>
+            <a:r>
+              <a:rPr lang="en-US"/>
+              <a:t>‹#›</a:t>
             </a:r>
           </a:p>
           <a:p>
@@ -4649,6 +5009,18 @@
           <a:p>
             <a:r>
               <a:rPr lang="en-US"/>
+              <a:t>1.7.2013</a:t>
+            </a:r>
+          </a:p>
+          <a:p>
+            <a:r>
+              <a:rPr lang="en-US"/>
+              <a:t/>
+            </a:r>
+          </a:p>
+          <a:p>
+            <a:r>
+              <a:rPr lang="en-US"/>
               <a:t>Demonstrate live with soap and water. The 'Give me five' poster turns the five steps into something children can count on their fingers. Technique based on WHO hand hygiene guidance.</a:t>
             </a:r>
           </a:p>
@@ -4656,6 +5028,18 @@
             <a:r>
               <a:rPr lang="en-US"/>
               <a:t>7</a:t>
+            </a:r>
+          </a:p>
+          <a:p>
+            <a:r>
+              <a:rPr lang="en-US"/>
+              <a:t/>
+            </a:r>
+          </a:p>
+          <a:p>
+            <a:r>
+              <a:rPr lang="en-US"/>
+              <a:t>‹#›</a:t>
             </a:r>
           </a:p>
           <a:p>
@@ -4915,6 +5299,18 @@
           <a:p>
             <a:r>
               <a:rPr lang="en-US"/>
+              <a:t>1.7.2013</a:t>
+            </a:r>
+          </a:p>
+          <a:p>
+            <a:r>
+              <a:rPr lang="en-US"/>
+              <a:t/>
+            </a:r>
+          </a:p>
+          <a:p>
+            <a:r>
+              <a:rPr lang="en-US"/>
               <a:t>Staying home when unwell should follow the school's and local health authorities' guidance. Each measure interrupts one route of transmission: droplets, shared objects or contaminated surfaces.</a:t>
             </a:r>
           </a:p>
@@ -4922,6 +5318,18 @@
             <a:r>
               <a:rPr lang="en-US"/>
               <a:t>8</a:t>
+            </a:r>
+          </a:p>
+          <a:p>
+            <a:r>
+              <a:rPr lang="en-US"/>
+              <a:t/>
+            </a:r>
+          </a:p>
+          <a:p>
+            <a:r>
+              <a:rPr lang="en-US"/>
+              <a:t>‹#›</a:t>
             </a:r>
           </a:p>
           <a:p>
@@ -5181,6 +5589,18 @@
           <a:p>
             <a:r>
               <a:rPr lang="en-US"/>
+              <a:t>1.7.2013</a:t>
+            </a:r>
+          </a:p>
+          <a:p>
+            <a:r>
+              <a:rPr lang="en-US"/>
+              <a:t/>
+            </a:r>
+          </a:p>
+          <a:p>
+            <a:r>
+              <a:rPr lang="en-US"/>
               <a:t>Children become active partners: besides protecting themselves, they are encouraged to report unsafe water, dirty toilets or unhygienic food areas to teachers.</a:t>
             </a:r>
           </a:p>
@@ -5188,6 +5608,18 @@
             <a:r>
               <a:rPr lang="en-US"/>
               <a:t>9</a:t>
+            </a:r>
+          </a:p>
+          <a:p>
+            <a:r>
+              <a:rPr lang="en-US"/>
+              <a:t/>
+            </a:r>
+          </a:p>
+          <a:p>
+            <a:r>
+              <a:rPr lang="en-US"/>
+              <a:t>‹#›</a:t>
             </a:r>
           </a:p>
           <a:p>
@@ -8254,8 +8686,8 @@
         </p:nvSpPr>
         <p:spPr>
           <a:xfrm rot="0">
-            <a:off x="1219200" y="1952777"/>
-            <a:ext cx="9104376" cy="382905"/>
+            <a:off x="1219200" y="1914677"/>
+            <a:ext cx="9104376" cy="421005"/>
           </a:xfrm>
           <a:prstGeom prst="rect">
             <a:avLst/>
@@ -8295,8 +8727,8 @@
         </p:nvSpPr>
         <p:spPr>
           <a:xfrm rot="0">
-            <a:off x="1219200" y="2977601"/>
-            <a:ext cx="9104376" cy="2845889"/>
+            <a:off x="1219200" y="3044276"/>
+            <a:ext cx="9104376" cy="2779214"/>
           </a:xfrm>
           <a:prstGeom prst="rect">
             <a:avLst/>
@@ -8336,8 +8768,8 @@
         </p:nvSpPr>
         <p:spPr>
           <a:xfrm rot="0">
-            <a:off x="1219200" y="6052099"/>
-            <a:ext cx="9104376" cy="952500"/>
+            <a:off x="1219200" y="6013999"/>
+            <a:ext cx="9104376" cy="990600"/>
           </a:xfrm>
           <a:prstGeom prst="rect">
             <a:avLst/>
@@ -8376,9 +8808,9 @@
           <p:nvPr/>
         </p:nvSpPr>
         <p:spPr>
-          <a:xfrm rot="48900">
-            <a:off x="568242" y="7950422"/>
-            <a:ext cx="1340025" cy="0"/>
+          <a:xfrm rot="48180">
+            <a:off x="558651" y="7940897"/>
+            <a:ext cx="1359208" cy="0"/>
           </a:xfrm>
           <a:prstGeom prst="line">
             <a:avLst/>
@@ -8401,8 +8833,8 @@
         </p:nvSpPr>
         <p:spPr>
           <a:xfrm rot="0">
-            <a:off x="1485900" y="7271299"/>
-            <a:ext cx="8829675" cy="552450"/>
+            <a:off x="1485900" y="7233199"/>
+            <a:ext cx="8829675" cy="590550"/>
           </a:xfrm>
           <a:prstGeom prst="rect">
             <a:avLst/>
@@ -8442,8 +8874,8 @@
         </p:nvSpPr>
         <p:spPr>
           <a:xfrm rot="0">
-            <a:off x="1485900" y="7747549"/>
-            <a:ext cx="8829675" cy="864298"/>
+            <a:off x="1485900" y="7709449"/>
+            <a:ext cx="8829675" cy="902398"/>
           </a:xfrm>
           <a:prstGeom prst="rect">
             <a:avLst/>
@@ -8610,7 +9042,7 @@
             <a:blipFill>
               <a:blip r:embed="rId4"/>
               <a:stretch>
-                <a:fillRect l="-205" t="0" r="-205" b="0"/>
+                <a:fillRect l="-224" t="0" r="-224" b="0"/>
               </a:stretch>
             </a:blipFill>
           </p:spPr>
@@ -8656,8 +9088,8 @@
         </p:nvSpPr>
         <p:spPr>
           <a:xfrm rot="0">
-            <a:off x="1219200" y="1104900"/>
-            <a:ext cx="16325088" cy="472383"/>
+            <a:off x="1219200" y="1066800"/>
+            <a:ext cx="16325088" cy="510483"/>
           </a:xfrm>
           <a:prstGeom prst="rect">
             <a:avLst/>
@@ -8697,8 +9129,8 @@
         </p:nvSpPr>
         <p:spPr>
           <a:xfrm rot="0">
-            <a:off x="1219200" y="1720158"/>
-            <a:ext cx="16325088" cy="672408"/>
+            <a:off x="1219200" y="1739208"/>
+            <a:ext cx="16325088" cy="653358"/>
           </a:xfrm>
           <a:prstGeom prst="rect">
             <a:avLst/>
@@ -8740,15 +9172,15 @@
         </p:nvGraphicFramePr>
         <p:xfrm>
           <a:off x="1219200" y="2811662"/>
-          <a:ext cx="15798800" cy="5486400"/>
+          <a:ext cx="15786100" cy="5486400"/>
         </p:xfrm>
         <a:graphic>
           <a:graphicData uri="http://schemas.openxmlformats.org/drawingml/2006/table">
             <a:tbl>
               <a:tblPr/>
               <a:tblGrid>
-                <a:gridCol w="5712219"/>
-                <a:gridCol w="10086581"/>
+                <a:gridCol w="5714632"/>
+                <a:gridCol w="10071468"/>
               </a:tblGrid>
               <a:tr h="685800">
                 <a:tc>
@@ -9866,8 +10298,8 @@
         </p:nvSpPr>
         <p:spPr>
           <a:xfrm rot="0">
-            <a:off x="1219200" y="9241184"/>
-            <a:ext cx="8225857" cy="472383"/>
+            <a:off x="1219200" y="9203084"/>
+            <a:ext cx="8225857" cy="510483"/>
           </a:xfrm>
           <a:prstGeom prst="rect">
             <a:avLst/>
@@ -9907,8 +10339,8 @@
         </p:nvSpPr>
         <p:spPr>
           <a:xfrm rot="0">
-            <a:off x="16794366" y="9241184"/>
-            <a:ext cx="350634" cy="472383"/>
+            <a:off x="16794366" y="9203084"/>
+            <a:ext cx="350634" cy="510483"/>
           </a:xfrm>
           <a:prstGeom prst="rect">
             <a:avLst/>
@@ -9980,8 +10412,8 @@
         </p:nvSpPr>
         <p:spPr>
           <a:xfrm rot="0">
-            <a:off x="1219200" y="1104900"/>
-            <a:ext cx="16325088" cy="472383"/>
+            <a:off x="1219200" y="1066800"/>
+            <a:ext cx="16325088" cy="510483"/>
           </a:xfrm>
           <a:prstGeom prst="rect">
             <a:avLst/>
@@ -10021,8 +10453,8 @@
         </p:nvSpPr>
         <p:spPr>
           <a:xfrm rot="0">
-            <a:off x="1219200" y="1720158"/>
-            <a:ext cx="16325088" cy="672408"/>
+            <a:off x="1219200" y="1739208"/>
+            <a:ext cx="16325088" cy="653358"/>
           </a:xfrm>
           <a:prstGeom prst="rect">
             <a:avLst/>
@@ -10062,7 +10494,7 @@
         </p:nvGrpSpPr>
         <p:grpSpPr>
           <a:xfrm rot="0">
-            <a:off x="978328" y="2937272"/>
+            <a:off x="978332" y="2937272"/>
             <a:ext cx="2466975" cy="3810000"/>
             <a:chOff x="0" y="0"/>
             <a:chExt cx="3289300" cy="5080000"/>
@@ -10109,7 +10541,7 @@
             <a:blipFill>
               <a:blip r:embed="rId3"/>
               <a:stretch>
-                <a:fillRect l="-148289" t="0" r="-148290" b="0"/>
+                <a:fillRect l="-148412" t="0" r="-148412" b="0"/>
               </a:stretch>
             </a:blipFill>
           </p:spPr>
@@ -10123,8 +10555,8 @@
         </p:nvSpPr>
         <p:spPr>
           <a:xfrm rot="0">
-            <a:off x="1219200" y="6823472"/>
-            <a:ext cx="2543175" cy="792366"/>
+            <a:off x="1219200" y="6785372"/>
+            <a:ext cx="2543175" cy="830466"/>
           </a:xfrm>
           <a:prstGeom prst="rect">
             <a:avLst/>
@@ -10164,10 +10596,10 @@
         </p:nvGrpSpPr>
         <p:grpSpPr>
           <a:xfrm rot="0">
-            <a:off x="3938207" y="2887866"/>
-            <a:ext cx="2990850" cy="3703287"/>
+            <a:off x="3938206" y="2887866"/>
+            <a:ext cx="2990850" cy="3703291"/>
             <a:chOff x="0" y="0"/>
-            <a:chExt cx="3987800" cy="4937716"/>
+            <a:chExt cx="3987800" cy="4937722"/>
           </a:xfrm>
         </p:grpSpPr>
         <p:sp>
@@ -10179,7 +10611,7 @@
           <p:spPr>
             <a:xfrm flipH="false" flipV="false" rot="0">
               <a:off x="0" y="0"/>
-              <a:ext cx="3987800" cy="4937716"/>
+              <a:ext cx="3987800" cy="4937760"/>
             </a:xfrm>
             <a:custGeom>
               <a:avLst/>
@@ -10188,7 +10620,7 @@
               <a:cxnLst/>
               <a:rect r="r" b="b" t="t" l="l"/>
               <a:pathLst>
-                <a:path h="4937716" w="3987800">
+                <a:path h="4937760" w="3987800">
                   <a:moveTo>
                     <a:pt x="0" y="0"/>
                   </a:moveTo>
@@ -10196,10 +10628,10 @@
                     <a:pt x="3987800" y="0"/>
                   </a:lnTo>
                   <a:lnTo>
-                    <a:pt x="3987800" y="4937716"/>
+                    <a:pt x="3987800" y="4937760"/>
                   </a:lnTo>
                   <a:lnTo>
-                    <a:pt x="0" y="4937716"/>
+                    <a:pt x="0" y="4937760"/>
                   </a:lnTo>
                   <a:lnTo>
                     <a:pt x="0" y="0"/>
@@ -10211,7 +10643,7 @@
             <a:blipFill>
               <a:blip r:embed="rId3"/>
               <a:stretch>
-                <a:fillRect l="-108976" t="0" r="-108976" b="0"/>
+                <a:fillRect l="-109075" t="0" r="-109074" b="0"/>
               </a:stretch>
             </a:blipFill>
           </p:spPr>
@@ -10225,8 +10657,8 @@
         </p:nvSpPr>
         <p:spPr>
           <a:xfrm rot="0">
-            <a:off x="4090002" y="6774066"/>
-            <a:ext cx="3080576" cy="792366"/>
+            <a:off x="4090006" y="6735966"/>
+            <a:ext cx="3080576" cy="830466"/>
           </a:xfrm>
           <a:prstGeom prst="rect">
             <a:avLst/>
@@ -10266,7 +10698,7 @@
         </p:nvGrpSpPr>
         <p:grpSpPr>
           <a:xfrm rot="0">
-            <a:off x="7491032" y="2781152"/>
+            <a:off x="7491032" y="2781148"/>
             <a:ext cx="3781425" cy="3810000"/>
             <a:chOff x="0" y="0"/>
             <a:chExt cx="5041900" cy="5080000"/>
@@ -10313,7 +10745,7 @@
             <a:blipFill>
               <a:blip r:embed="rId4"/>
               <a:stretch>
-                <a:fillRect l="-25818" t="0" r="-25818" b="0"/>
+                <a:fillRect l="-25881" t="0" r="-25881" b="0"/>
               </a:stretch>
             </a:blipFill>
           </p:spPr>
@@ -10327,8 +10759,8 @@
         </p:nvSpPr>
         <p:spPr>
           <a:xfrm rot="0">
-            <a:off x="7943945" y="6730194"/>
-            <a:ext cx="3894868" cy="344805"/>
+            <a:off x="7943945" y="6692094"/>
+            <a:ext cx="3894868" cy="382905"/>
           </a:xfrm>
           <a:prstGeom prst="rect">
             <a:avLst/>
@@ -10415,7 +10847,7 @@
             <a:blipFill>
               <a:blip r:embed="rId5"/>
               <a:stretch>
-                <a:fillRect l="-250" t="0" r="-250" b="0"/>
+                <a:fillRect l="-292" t="0" r="-292" b="0"/>
               </a:stretch>
             </a:blipFill>
           </p:spPr>
@@ -10429,8 +10861,8 @@
         </p:nvSpPr>
         <p:spPr>
           <a:xfrm rot="0">
-            <a:off x="12130057" y="6659766"/>
-            <a:ext cx="5876639" cy="472383"/>
+            <a:off x="12130059" y="6621666"/>
+            <a:ext cx="5876639" cy="510483"/>
           </a:xfrm>
           <a:prstGeom prst="rect">
             <a:avLst/>
@@ -10470,8 +10902,8 @@
         </p:nvSpPr>
         <p:spPr>
           <a:xfrm rot="0">
-            <a:off x="1219200" y="7756922"/>
-            <a:ext cx="16325088" cy="472383"/>
+            <a:off x="1219200" y="7718822"/>
+            <a:ext cx="16325088" cy="510483"/>
           </a:xfrm>
           <a:prstGeom prst="rect">
             <a:avLst/>
@@ -10511,8 +10943,8 @@
         </p:nvSpPr>
         <p:spPr>
           <a:xfrm rot="0">
-            <a:off x="1219200" y="9241184"/>
-            <a:ext cx="8225857" cy="472383"/>
+            <a:off x="1219200" y="9203084"/>
+            <a:ext cx="8225857" cy="510483"/>
           </a:xfrm>
           <a:prstGeom prst="rect">
             <a:avLst/>
@@ -10552,8 +10984,8 @@
         </p:nvSpPr>
         <p:spPr>
           <a:xfrm rot="0">
-            <a:off x="16794366" y="9241184"/>
-            <a:ext cx="350634" cy="472383"/>
+            <a:off x="16794366" y="9203084"/>
+            <a:ext cx="350634" cy="510483"/>
           </a:xfrm>
           <a:prstGeom prst="rect">
             <a:avLst/>
@@ -10593,7 +11025,7 @@
         </p:nvGrpSpPr>
         <p:grpSpPr>
           <a:xfrm rot="0">
-            <a:off x="978328" y="2937272"/>
+            <a:off x="978332" y="2937272"/>
             <a:ext cx="2466975" cy="3810000"/>
             <a:chOff x="0" y="0"/>
             <a:chExt cx="3289300" cy="5080000"/>
@@ -10640,7 +11072,7 @@
             <a:blipFill>
               <a:blip r:embed="rId6"/>
               <a:stretch>
-                <a:fillRect l="-66216" t="0" r="-66216" b="0"/>
+                <a:fillRect l="-66312" t="0" r="-66312" b="0"/>
               </a:stretch>
             </a:blipFill>
           </p:spPr>
@@ -10654,7 +11086,7 @@
         </p:nvGrpSpPr>
         <p:grpSpPr>
           <a:xfrm rot="0">
-            <a:off x="3938207" y="2887866"/>
+            <a:off x="3938206" y="2887866"/>
             <a:ext cx="2990850" cy="3810000"/>
             <a:chOff x="0" y="0"/>
             <a:chExt cx="3987800" cy="5080000"/>
@@ -10701,7 +11133,7 @@
             <a:blipFill>
               <a:blip r:embed="rId7"/>
               <a:stretch>
-                <a:fillRect l="-45859" t="0" r="-45859" b="0"/>
+                <a:fillRect l="-45939" t="0" r="-45939" b="0"/>
               </a:stretch>
             </a:blipFill>
           </p:spPr>
@@ -10747,8 +11179,8 @@
         </p:nvSpPr>
         <p:spPr>
           <a:xfrm rot="0">
-            <a:off x="1219200" y="1104900"/>
-            <a:ext cx="16325088" cy="472383"/>
+            <a:off x="1219200" y="1066800"/>
+            <a:ext cx="16325088" cy="510483"/>
           </a:xfrm>
           <a:prstGeom prst="rect">
             <a:avLst/>
@@ -10788,8 +11220,8 @@
         </p:nvSpPr>
         <p:spPr>
           <a:xfrm rot="0">
-            <a:off x="1219200" y="1720158"/>
-            <a:ext cx="16325088" cy="672408"/>
+            <a:off x="1219200" y="1739208"/>
+            <a:ext cx="16325088" cy="653358"/>
           </a:xfrm>
           <a:prstGeom prst="rect">
             <a:avLst/>
@@ -10881,8 +11313,8 @@
         </p:nvSpPr>
         <p:spPr>
           <a:xfrm rot="0">
-            <a:off x="1571625" y="2973591"/>
-            <a:ext cx="4506354" cy="472383"/>
+            <a:off x="1571625" y="2935491"/>
+            <a:ext cx="4506354" cy="510483"/>
           </a:xfrm>
           <a:prstGeom prst="rect">
             <a:avLst/>
@@ -10963,8 +11395,8 @@
         </p:nvSpPr>
         <p:spPr>
           <a:xfrm rot="0">
-            <a:off x="1571625" y="3903164"/>
-            <a:ext cx="4506354" cy="952500"/>
+            <a:off x="1571625" y="3865064"/>
+            <a:ext cx="4506354" cy="990600"/>
           </a:xfrm>
           <a:prstGeom prst="rect">
             <a:avLst/>
@@ -11056,8 +11488,8 @@
         </p:nvSpPr>
         <p:spPr>
           <a:xfrm rot="0">
-            <a:off x="6956374" y="2973591"/>
-            <a:ext cx="4506354" cy="472383"/>
+            <a:off x="6956374" y="2935491"/>
+            <a:ext cx="4506354" cy="510483"/>
           </a:xfrm>
           <a:prstGeom prst="rect">
             <a:avLst/>
@@ -11138,8 +11570,8 @@
         </p:nvSpPr>
         <p:spPr>
           <a:xfrm rot="0">
-            <a:off x="6956374" y="3903164"/>
-            <a:ext cx="4506354" cy="952500"/>
+            <a:off x="6956374" y="3865064"/>
+            <a:ext cx="4506354" cy="990600"/>
           </a:xfrm>
           <a:prstGeom prst="rect">
             <a:avLst/>
@@ -11231,8 +11663,8 @@
         </p:nvSpPr>
         <p:spPr>
           <a:xfrm rot="0">
-            <a:off x="12341123" y="2973591"/>
-            <a:ext cx="4506354" cy="472383"/>
+            <a:off x="12341123" y="2935491"/>
+            <a:ext cx="4506354" cy="510483"/>
           </a:xfrm>
           <a:prstGeom prst="rect">
             <a:avLst/>
@@ -11313,8 +11745,8 @@
         </p:nvSpPr>
         <p:spPr>
           <a:xfrm rot="0">
-            <a:off x="12341123" y="3903164"/>
-            <a:ext cx="4506354" cy="952500"/>
+            <a:off x="12341123" y="3865064"/>
+            <a:ext cx="4506354" cy="990600"/>
           </a:xfrm>
           <a:prstGeom prst="rect">
             <a:avLst/>
@@ -11406,8 +11838,8 @@
         </p:nvSpPr>
         <p:spPr>
           <a:xfrm rot="0">
-            <a:off x="1571625" y="5560514"/>
-            <a:ext cx="4506354" cy="472383"/>
+            <a:off x="1571625" y="5522414"/>
+            <a:ext cx="4506354" cy="510483"/>
           </a:xfrm>
           <a:prstGeom prst="rect">
             <a:avLst/>
@@ -11488,8 +11920,8 @@
         </p:nvSpPr>
         <p:spPr>
           <a:xfrm rot="0">
-            <a:off x="1571625" y="6490097"/>
-            <a:ext cx="4506354" cy="952500"/>
+            <a:off x="1571625" y="6451997"/>
+            <a:ext cx="4506354" cy="990600"/>
           </a:xfrm>
           <a:prstGeom prst="rect">
             <a:avLst/>
@@ -11581,8 +12013,8 @@
         </p:nvSpPr>
         <p:spPr>
           <a:xfrm rot="0">
-            <a:off x="6956374" y="5560514"/>
-            <a:ext cx="4506354" cy="472383"/>
+            <a:off x="6956374" y="5522414"/>
+            <a:ext cx="4506354" cy="510483"/>
           </a:xfrm>
           <a:prstGeom prst="rect">
             <a:avLst/>
@@ -11663,8 +12095,8 @@
         </p:nvSpPr>
         <p:spPr>
           <a:xfrm rot="0">
-            <a:off x="6956374" y="6490097"/>
-            <a:ext cx="4506354" cy="952500"/>
+            <a:off x="6956374" y="6451997"/>
+            <a:ext cx="4506354" cy="990600"/>
           </a:xfrm>
           <a:prstGeom prst="rect">
             <a:avLst/>
@@ -11756,8 +12188,8 @@
         </p:nvSpPr>
         <p:spPr>
           <a:xfrm rot="0">
-            <a:off x="12341123" y="5560514"/>
-            <a:ext cx="4506354" cy="472383"/>
+            <a:off x="12341123" y="5522414"/>
+            <a:ext cx="4506354" cy="510483"/>
           </a:xfrm>
           <a:prstGeom prst="rect">
             <a:avLst/>
@@ -11838,8 +12270,8 @@
         </p:nvSpPr>
         <p:spPr>
           <a:xfrm rot="0">
-            <a:off x="12341123" y="6490097"/>
-            <a:ext cx="4506354" cy="952500"/>
+            <a:off x="12341123" y="6451997"/>
+            <a:ext cx="4506354" cy="990600"/>
           </a:xfrm>
           <a:prstGeom prst="rect">
             <a:avLst/>
@@ -11879,8 +12311,8 @@
         </p:nvSpPr>
         <p:spPr>
           <a:xfrm rot="0">
-            <a:off x="1219200" y="9241184"/>
-            <a:ext cx="8225857" cy="472383"/>
+            <a:off x="1219200" y="9203084"/>
+            <a:ext cx="8225857" cy="510483"/>
           </a:xfrm>
           <a:prstGeom prst="rect">
             <a:avLst/>
@@ -11920,8 +12352,8 @@
         </p:nvSpPr>
         <p:spPr>
           <a:xfrm rot="0">
-            <a:off x="16794366" y="9241184"/>
-            <a:ext cx="350634" cy="472383"/>
+            <a:off x="16794366" y="9203084"/>
+            <a:ext cx="350634" cy="510483"/>
           </a:xfrm>
           <a:prstGeom prst="rect">
             <a:avLst/>
@@ -12053,8 +12485,8 @@
         </p:nvSpPr>
         <p:spPr>
           <a:xfrm rot="0">
-            <a:off x="1219200" y="1104900"/>
-            <a:ext cx="16325088" cy="472383"/>
+            <a:off x="1219200" y="1066800"/>
+            <a:ext cx="16325088" cy="510483"/>
           </a:xfrm>
           <a:prstGeom prst="rect">
             <a:avLst/>
@@ -12094,8 +12526,8 @@
         </p:nvSpPr>
         <p:spPr>
           <a:xfrm rot="0">
-            <a:off x="1219200" y="1720158"/>
-            <a:ext cx="16325088" cy="672408"/>
+            <a:off x="1219200" y="1739208"/>
+            <a:ext cx="16325088" cy="653358"/>
           </a:xfrm>
           <a:prstGeom prst="rect">
             <a:avLst/>
@@ -12228,8 +12660,8 @@
         </p:nvSpPr>
         <p:spPr>
           <a:xfrm rot="0">
-            <a:off x="1609725" y="3621291"/>
-            <a:ext cx="7201090" cy="952500"/>
+            <a:off x="1609725" y="3583191"/>
+            <a:ext cx="7201090" cy="990600"/>
           </a:xfrm>
           <a:prstGeom prst="rect">
             <a:avLst/>
@@ -12362,8 +12794,8 @@
         </p:nvSpPr>
         <p:spPr>
           <a:xfrm rot="0">
-            <a:off x="9686925" y="3621291"/>
-            <a:ext cx="7201090" cy="952500"/>
+            <a:off x="9686925" y="3583191"/>
+            <a:ext cx="7201090" cy="990600"/>
           </a:xfrm>
           <a:prstGeom prst="rect">
             <a:avLst/>
@@ -12496,8 +12928,8 @@
         </p:nvSpPr>
         <p:spPr>
           <a:xfrm rot="0">
-            <a:off x="1609725" y="6002541"/>
-            <a:ext cx="7201090" cy="952500"/>
+            <a:off x="1609725" y="5964441"/>
+            <a:ext cx="7201090" cy="990600"/>
           </a:xfrm>
           <a:prstGeom prst="rect">
             <a:avLst/>
@@ -12630,8 +13062,8 @@
         </p:nvSpPr>
         <p:spPr>
           <a:xfrm rot="0">
-            <a:off x="9686925" y="6002541"/>
-            <a:ext cx="7201090" cy="952500"/>
+            <a:off x="9686925" y="5964441"/>
+            <a:ext cx="7201090" cy="990600"/>
           </a:xfrm>
           <a:prstGeom prst="rect">
             <a:avLst/>
@@ -12671,8 +13103,8 @@
         </p:nvSpPr>
         <p:spPr>
           <a:xfrm rot="0">
-            <a:off x="1219200" y="9241184"/>
-            <a:ext cx="8225857" cy="472383"/>
+            <a:off x="1219200" y="9203084"/>
+            <a:ext cx="8225857" cy="510483"/>
           </a:xfrm>
           <a:prstGeom prst="rect">
             <a:avLst/>
@@ -12712,8 +13144,8 @@
         </p:nvSpPr>
         <p:spPr>
           <a:xfrm rot="0">
-            <a:off x="16794366" y="9241184"/>
-            <a:ext cx="350634" cy="472383"/>
+            <a:off x="16794366" y="9203084"/>
+            <a:ext cx="350634" cy="510483"/>
           </a:xfrm>
           <a:prstGeom prst="rect">
             <a:avLst/>
@@ -12785,8 +13217,8 @@
         </p:nvSpPr>
         <p:spPr>
           <a:xfrm rot="0">
-            <a:off x="1219200" y="1104900"/>
-            <a:ext cx="16325088" cy="306705"/>
+            <a:off x="1219200" y="1066800"/>
+            <a:ext cx="16325088" cy="344805"/>
           </a:xfrm>
           <a:prstGeom prst="rect">
             <a:avLst/>
@@ -12826,8 +13258,8 @@
         </p:nvSpPr>
         <p:spPr>
           <a:xfrm rot="0">
-            <a:off x="1219200" y="1720158"/>
-            <a:ext cx="16325088" cy="672408"/>
+            <a:off x="1219200" y="1739208"/>
+            <a:ext cx="16325088" cy="653358"/>
           </a:xfrm>
           <a:prstGeom prst="rect">
             <a:avLst/>
@@ -12928,8 +13360,8 @@
         </p:nvSpPr>
         <p:spPr>
           <a:xfrm rot="0">
-            <a:off x="1785337" y="2697366"/>
-            <a:ext cx="7108498" cy="952500"/>
+            <a:off x="1785337" y="2659266"/>
+            <a:ext cx="7108498" cy="990600"/>
           </a:xfrm>
           <a:prstGeom prst="rect">
             <a:avLst/>
@@ -13030,8 +13462,8 @@
         </p:nvSpPr>
         <p:spPr>
           <a:xfrm rot="0">
-            <a:off x="1841449" y="3954666"/>
-            <a:ext cx="7050710" cy="952500"/>
+            <a:off x="1841449" y="3916566"/>
+            <a:ext cx="7050710" cy="990600"/>
           </a:xfrm>
           <a:prstGeom prst="rect">
             <a:avLst/>
@@ -13132,8 +13564,8 @@
         </p:nvSpPr>
         <p:spPr>
           <a:xfrm rot="0">
-            <a:off x="1866900" y="5211966"/>
-            <a:ext cx="6862162" cy="552450"/>
+            <a:off x="1866900" y="5173866"/>
+            <a:ext cx="6862162" cy="590550"/>
           </a:xfrm>
           <a:prstGeom prst="rect">
             <a:avLst/>
@@ -13234,8 +13666,8 @@
         </p:nvSpPr>
         <p:spPr>
           <a:xfrm rot="0">
-            <a:off x="10168385" y="2697366"/>
-            <a:ext cx="7107431" cy="952500"/>
+            <a:off x="10168385" y="2659266"/>
+            <a:ext cx="7107431" cy="990600"/>
           </a:xfrm>
           <a:prstGeom prst="rect">
             <a:avLst/>
@@ -13336,8 +13768,8 @@
         </p:nvSpPr>
         <p:spPr>
           <a:xfrm rot="0">
-            <a:off x="10170471" y="3954666"/>
-            <a:ext cx="7105279" cy="952500"/>
+            <a:off x="10170471" y="3916566"/>
+            <a:ext cx="7105279" cy="990600"/>
           </a:xfrm>
           <a:prstGeom prst="rect">
             <a:avLst/>
@@ -13438,8 +13870,8 @@
         </p:nvSpPr>
         <p:spPr>
           <a:xfrm rot="0">
-            <a:off x="10183120" y="5211966"/>
-            <a:ext cx="7092248" cy="952500"/>
+            <a:off x="10183120" y="5173866"/>
+            <a:ext cx="7092248" cy="990600"/>
           </a:xfrm>
           <a:prstGeom prst="rect">
             <a:avLst/>
@@ -13479,8 +13911,8 @@
         </p:nvSpPr>
         <p:spPr>
           <a:xfrm rot="0">
-            <a:off x="1219200" y="9241184"/>
-            <a:ext cx="8225857" cy="472383"/>
+            <a:off x="1219200" y="9203084"/>
+            <a:ext cx="8225857" cy="510483"/>
           </a:xfrm>
           <a:prstGeom prst="rect">
             <a:avLst/>
@@ -13520,8 +13952,8 @@
         </p:nvSpPr>
         <p:spPr>
           <a:xfrm rot="0">
-            <a:off x="16794366" y="9241184"/>
-            <a:ext cx="350634" cy="472383"/>
+            <a:off x="16794366" y="9203084"/>
+            <a:ext cx="350634" cy="510483"/>
           </a:xfrm>
           <a:prstGeom prst="rect">
             <a:avLst/>
@@ -13593,8 +14025,8 @@
         </p:nvSpPr>
         <p:spPr>
           <a:xfrm rot="0">
-            <a:off x="1219200" y="1104900"/>
-            <a:ext cx="16325088" cy="472383"/>
+            <a:off x="1219200" y="1066800"/>
+            <a:ext cx="16325088" cy="510483"/>
           </a:xfrm>
           <a:prstGeom prst="rect">
             <a:avLst/>
@@ -13634,8 +14066,8 @@
         </p:nvSpPr>
         <p:spPr>
           <a:xfrm rot="0">
-            <a:off x="1219200" y="1720158"/>
-            <a:ext cx="16325088" cy="672408"/>
+            <a:off x="1219200" y="1739208"/>
+            <a:ext cx="16325088" cy="653358"/>
           </a:xfrm>
           <a:prstGeom prst="rect">
             <a:avLst/>
@@ -13677,16 +14109,16 @@
         </p:nvGraphicFramePr>
         <p:xfrm>
           <a:off x="1219200" y="2811662"/>
-          <a:ext cx="15786100" cy="4800600"/>
+          <a:ext cx="15760700" cy="4800600"/>
         </p:xfrm>
         <a:graphic>
           <a:graphicData uri="http://schemas.openxmlformats.org/drawingml/2006/table">
             <a:tbl>
               <a:tblPr/>
               <a:tblGrid>
-                <a:gridCol w="5986449"/>
-                <a:gridCol w="5675984"/>
-                <a:gridCol w="4123667"/>
+                <a:gridCol w="5973342"/>
+                <a:gridCol w="5664866"/>
+                <a:gridCol w="4122492"/>
               </a:tblGrid>
               <a:tr h="685800">
                 <a:tc>
@@ -15142,8 +15574,8 @@
         </p:nvSpPr>
         <p:spPr>
           <a:xfrm rot="0">
-            <a:off x="1219200" y="7983741"/>
-            <a:ext cx="16325088" cy="552450"/>
+            <a:off x="1219200" y="7945641"/>
+            <a:ext cx="16325088" cy="590550"/>
           </a:xfrm>
           <a:prstGeom prst="rect">
             <a:avLst/>
@@ -15183,8 +15615,8 @@
         </p:nvSpPr>
         <p:spPr>
           <a:xfrm rot="0">
-            <a:off x="1219200" y="9241184"/>
-            <a:ext cx="8225857" cy="472383"/>
+            <a:off x="1219200" y="9203084"/>
+            <a:ext cx="8225857" cy="510483"/>
           </a:xfrm>
           <a:prstGeom prst="rect">
             <a:avLst/>
@@ -15224,8 +15656,8 @@
         </p:nvSpPr>
         <p:spPr>
           <a:xfrm rot="0">
-            <a:off x="16794366" y="9241184"/>
-            <a:ext cx="350634" cy="472383"/>
+            <a:off x="16794366" y="9203084"/>
+            <a:ext cx="350634" cy="510483"/>
           </a:xfrm>
           <a:prstGeom prst="rect">
             <a:avLst/>
@@ -15297,8 +15729,8 @@
         </p:nvSpPr>
         <p:spPr>
           <a:xfrm rot="0">
-            <a:off x="1219200" y="1104900"/>
-            <a:ext cx="16325088" cy="472383"/>
+            <a:off x="1219200" y="1066800"/>
+            <a:ext cx="16325088" cy="510483"/>
           </a:xfrm>
           <a:prstGeom prst="rect">
             <a:avLst/>
@@ -15338,8 +15770,8 @@
         </p:nvSpPr>
         <p:spPr>
           <a:xfrm rot="0">
-            <a:off x="1219200" y="1720158"/>
-            <a:ext cx="16325088" cy="672408"/>
+            <a:off x="1219200" y="1739208"/>
+            <a:ext cx="16325088" cy="653358"/>
           </a:xfrm>
           <a:prstGeom prst="rect">
             <a:avLst/>
@@ -15420,8 +15852,8 @@
         </p:nvSpPr>
         <p:spPr>
           <a:xfrm rot="6540">
-            <a:off x="1200121" y="7314305"/>
-            <a:ext cx="5016456" cy="0"/>
+            <a:off x="1195349" y="7309542"/>
+            <a:ext cx="5025990" cy="0"/>
           </a:xfrm>
           <a:prstGeom prst="line">
             <a:avLst/>
@@ -15444,8 +15876,8 @@
         </p:nvSpPr>
         <p:spPr>
           <a:xfrm rot="0">
-            <a:off x="1219200" y="7452417"/>
-            <a:ext cx="5127650" cy="472383"/>
+            <a:off x="1219200" y="7414317"/>
+            <a:ext cx="5127650" cy="510483"/>
           </a:xfrm>
           <a:prstGeom prst="rect">
             <a:avLst/>
@@ -15485,8 +15917,8 @@
         </p:nvSpPr>
         <p:spPr>
           <a:xfrm rot="0">
-            <a:off x="1219200" y="7848600"/>
-            <a:ext cx="5127650" cy="952500"/>
+            <a:off x="1219200" y="7810500"/>
+            <a:ext cx="5127650" cy="990600"/>
           </a:xfrm>
           <a:prstGeom prst="rect">
             <a:avLst/>
@@ -15526,8 +15958,8 @@
         </p:nvSpPr>
         <p:spPr>
           <a:xfrm rot="6540">
-            <a:off x="6635610" y="7314305"/>
-            <a:ext cx="5016608" cy="0"/>
+            <a:off x="6630838" y="7309542"/>
+            <a:ext cx="5026142" cy="0"/>
           </a:xfrm>
           <a:prstGeom prst="line">
             <a:avLst/>
@@ -15550,8 +15982,8 @@
         </p:nvSpPr>
         <p:spPr>
           <a:xfrm rot="0">
-            <a:off x="6654698" y="7452417"/>
-            <a:ext cx="5127803" cy="472383"/>
+            <a:off x="6654698" y="7414317"/>
+            <a:ext cx="5127803" cy="510483"/>
           </a:xfrm>
           <a:prstGeom prst="rect">
             <a:avLst/>
@@ -15591,8 +16023,8 @@
         </p:nvSpPr>
         <p:spPr>
           <a:xfrm rot="0">
-            <a:off x="6654698" y="7848600"/>
-            <a:ext cx="5127803" cy="952500"/>
+            <a:off x="6654698" y="7810500"/>
+            <a:ext cx="5127803" cy="990600"/>
           </a:xfrm>
           <a:prstGeom prst="rect">
             <a:avLst/>
@@ -15632,8 +16064,8 @@
         </p:nvSpPr>
         <p:spPr>
           <a:xfrm rot="6540">
-            <a:off x="12071280" y="7314305"/>
-            <a:ext cx="5016608" cy="0"/>
+            <a:off x="12066518" y="7309542"/>
+            <a:ext cx="5026142" cy="0"/>
           </a:xfrm>
           <a:prstGeom prst="line">
             <a:avLst/>
@@ -15656,8 +16088,8 @@
         </p:nvSpPr>
         <p:spPr>
           <a:xfrm rot="0">
-            <a:off x="12090349" y="7452417"/>
-            <a:ext cx="5127803" cy="472383"/>
+            <a:off x="12090349" y="7414317"/>
+            <a:ext cx="5127803" cy="510483"/>
           </a:xfrm>
           <a:prstGeom prst="rect">
             <a:avLst/>
@@ -15697,8 +16129,8 @@
         </p:nvSpPr>
         <p:spPr>
           <a:xfrm rot="0">
-            <a:off x="12090349" y="7848600"/>
-            <a:ext cx="5127803" cy="952500"/>
+            <a:off x="12090349" y="7810500"/>
+            <a:ext cx="5127803" cy="990600"/>
           </a:xfrm>
           <a:prstGeom prst="rect">
             <a:avLst/>
@@ -15738,8 +16170,8 @@
         </p:nvSpPr>
         <p:spPr>
           <a:xfrm rot="0">
-            <a:off x="1219200" y="9241184"/>
-            <a:ext cx="8225857" cy="472383"/>
+            <a:off x="1219200" y="9203084"/>
+            <a:ext cx="8225857" cy="510483"/>
           </a:xfrm>
           <a:prstGeom prst="rect">
             <a:avLst/>
@@ -15779,8 +16211,8 @@
         </p:nvSpPr>
         <p:spPr>
           <a:xfrm rot="0">
-            <a:off x="16794366" y="9241184"/>
-            <a:ext cx="350634" cy="472383"/>
+            <a:off x="16794366" y="9203084"/>
+            <a:ext cx="350634" cy="510483"/>
           </a:xfrm>
           <a:prstGeom prst="rect">
             <a:avLst/>
@@ -15852,8 +16284,8 @@
         </p:nvSpPr>
         <p:spPr>
           <a:xfrm rot="0">
-            <a:off x="1219200" y="1104900"/>
-            <a:ext cx="16325088" cy="472383"/>
+            <a:off x="1219200" y="1066800"/>
+            <a:ext cx="16325088" cy="510483"/>
           </a:xfrm>
           <a:prstGeom prst="rect">
             <a:avLst/>
@@ -15893,8 +16325,8 @@
         </p:nvSpPr>
         <p:spPr>
           <a:xfrm rot="0">
-            <a:off x="1219200" y="1720158"/>
-            <a:ext cx="16325088" cy="672408"/>
+            <a:off x="1219200" y="1739208"/>
+            <a:ext cx="16325088" cy="653358"/>
           </a:xfrm>
           <a:prstGeom prst="rect">
             <a:avLst/>
@@ -15934,8 +16366,8 @@
         </p:nvSpPr>
         <p:spPr>
           <a:xfrm rot="2040">
-            <a:off x="1204912" y="3887276"/>
-            <a:ext cx="15878175" cy="0"/>
+            <a:off x="1200150" y="3882514"/>
+            <a:ext cx="15887700" cy="0"/>
           </a:xfrm>
           <a:prstGeom prst="line">
             <a:avLst/>
@@ -15958,8 +16390,8 @@
         </p:nvSpPr>
         <p:spPr>
           <a:xfrm rot="0">
-            <a:off x="1219200" y="2849766"/>
-            <a:ext cx="609600" cy="552450"/>
+            <a:off x="1219200" y="2811666"/>
+            <a:ext cx="609600" cy="590550"/>
           </a:xfrm>
           <a:prstGeom prst="rect">
             <a:avLst/>
@@ -15999,8 +16431,8 @@
         </p:nvSpPr>
         <p:spPr>
           <a:xfrm rot="0">
-            <a:off x="1981200" y="2764041"/>
-            <a:ext cx="15540228" cy="1040025"/>
+            <a:off x="1981200" y="2697366"/>
+            <a:ext cx="15540228" cy="1106700"/>
           </a:xfrm>
           <a:prstGeom prst="rect">
             <a:avLst/>
@@ -16064,8 +16496,8 @@
         </p:nvSpPr>
         <p:spPr>
           <a:xfrm rot="2040">
-            <a:off x="1204912" y="4907270"/>
-            <a:ext cx="15878175" cy="0"/>
+            <a:off x="1200150" y="4902508"/>
+            <a:ext cx="15887700" cy="0"/>
           </a:xfrm>
           <a:prstGeom prst="line">
             <a:avLst/>
@@ -16088,8 +16520,8 @@
         </p:nvSpPr>
         <p:spPr>
           <a:xfrm rot="0">
-            <a:off x="1219200" y="3869760"/>
-            <a:ext cx="609600" cy="552450"/>
+            <a:off x="1219200" y="3831660"/>
+            <a:ext cx="609600" cy="590550"/>
           </a:xfrm>
           <a:prstGeom prst="rect">
             <a:avLst/>
@@ -16129,8 +16561,8 @@
         </p:nvSpPr>
         <p:spPr>
           <a:xfrm rot="0">
-            <a:off x="1981200" y="3784035"/>
-            <a:ext cx="15540228" cy="1040025"/>
+            <a:off x="1981200" y="3717360"/>
+            <a:ext cx="15540228" cy="1106700"/>
           </a:xfrm>
           <a:prstGeom prst="rect">
             <a:avLst/>
@@ -16194,8 +16626,8 @@
         </p:nvSpPr>
         <p:spPr>
           <a:xfrm rot="2040">
-            <a:off x="1204912" y="5927274"/>
-            <a:ext cx="15878175" cy="0"/>
+            <a:off x="1200150" y="5922512"/>
+            <a:ext cx="15887700" cy="0"/>
           </a:xfrm>
           <a:prstGeom prst="line">
             <a:avLst/>
@@ -16218,8 +16650,8 @@
         </p:nvSpPr>
         <p:spPr>
           <a:xfrm rot="0">
-            <a:off x="1219200" y="4889764"/>
-            <a:ext cx="609600" cy="552450"/>
+            <a:off x="1219200" y="4851664"/>
+            <a:ext cx="609600" cy="590550"/>
           </a:xfrm>
           <a:prstGeom prst="rect">
             <a:avLst/>
@@ -16259,8 +16691,8 @@
         </p:nvSpPr>
         <p:spPr>
           <a:xfrm rot="0">
-            <a:off x="1981200" y="4804039"/>
-            <a:ext cx="15540228" cy="1040025"/>
+            <a:off x="1981200" y="4737364"/>
+            <a:ext cx="15540228" cy="1106700"/>
           </a:xfrm>
           <a:prstGeom prst="rect">
             <a:avLst/>
@@ -16324,8 +16756,8 @@
         </p:nvSpPr>
         <p:spPr>
           <a:xfrm rot="2040">
-            <a:off x="1204912" y="6947278"/>
-            <a:ext cx="15878175" cy="0"/>
+            <a:off x="1200150" y="6942515"/>
+            <a:ext cx="15887700" cy="0"/>
           </a:xfrm>
           <a:prstGeom prst="line">
             <a:avLst/>
@@ -16348,8 +16780,8 @@
         </p:nvSpPr>
         <p:spPr>
           <a:xfrm rot="0">
-            <a:off x="1219200" y="5909758"/>
-            <a:ext cx="609600" cy="552450"/>
+            <a:off x="1219200" y="5871658"/>
+            <a:ext cx="609600" cy="590550"/>
           </a:xfrm>
           <a:prstGeom prst="rect">
             <a:avLst/>
@@ -16389,8 +16821,8 @@
         </p:nvSpPr>
         <p:spPr>
           <a:xfrm rot="0">
-            <a:off x="1981200" y="5824033"/>
-            <a:ext cx="15540228" cy="1040025"/>
+            <a:off x="1981200" y="5757358"/>
+            <a:ext cx="15540228" cy="1106700"/>
           </a:xfrm>
           <a:prstGeom prst="rect">
             <a:avLst/>
@@ -16454,8 +16886,8 @@
         </p:nvSpPr>
         <p:spPr>
           <a:xfrm rot="2040">
-            <a:off x="1204912" y="7967272"/>
-            <a:ext cx="15878175" cy="0"/>
+            <a:off x="1200150" y="7962509"/>
+            <a:ext cx="15887700" cy="0"/>
           </a:xfrm>
           <a:prstGeom prst="line">
             <a:avLst/>
@@ -16478,8 +16910,8 @@
         </p:nvSpPr>
         <p:spPr>
           <a:xfrm rot="0">
-            <a:off x="1219200" y="6929761"/>
-            <a:ext cx="609600" cy="552450"/>
+            <a:off x="1219200" y="6891661"/>
+            <a:ext cx="609600" cy="590550"/>
           </a:xfrm>
           <a:prstGeom prst="rect">
             <a:avLst/>
@@ -16519,8 +16951,8 @@
         </p:nvSpPr>
         <p:spPr>
           <a:xfrm rot="0">
-            <a:off x="1981200" y="6844036"/>
-            <a:ext cx="15540228" cy="1040025"/>
+            <a:off x="1981200" y="6777361"/>
+            <a:ext cx="15540228" cy="1106700"/>
           </a:xfrm>
           <a:prstGeom prst="rect">
             <a:avLst/>
@@ -16584,8 +17016,8 @@
         </p:nvSpPr>
         <p:spPr>
           <a:xfrm rot="0">
-            <a:off x="1219200" y="7949765"/>
-            <a:ext cx="609600" cy="552450"/>
+            <a:off x="1219200" y="7911665"/>
+            <a:ext cx="609600" cy="590550"/>
           </a:xfrm>
           <a:prstGeom prst="rect">
             <a:avLst/>
@@ -16625,8 +17057,8 @@
         </p:nvSpPr>
         <p:spPr>
           <a:xfrm rot="0">
-            <a:off x="1981200" y="7864040"/>
-            <a:ext cx="15540228" cy="1040025"/>
+            <a:off x="1981200" y="7797365"/>
+            <a:ext cx="15540228" cy="1106700"/>
           </a:xfrm>
           <a:prstGeom prst="rect">
             <a:avLst/>
@@ -16666,8 +17098,8 @@
         </p:nvSpPr>
         <p:spPr>
           <a:xfrm rot="0">
-            <a:off x="1219200" y="9241184"/>
-            <a:ext cx="8225857" cy="472383"/>
+            <a:off x="1219200" y="9203084"/>
+            <a:ext cx="8225857" cy="510483"/>
           </a:xfrm>
           <a:prstGeom prst="rect">
             <a:avLst/>
@@ -16707,8 +17139,8 @@
         </p:nvSpPr>
         <p:spPr>
           <a:xfrm rot="0">
-            <a:off x="16794366" y="9241184"/>
-            <a:ext cx="350634" cy="472383"/>
+            <a:off x="16794366" y="9203084"/>
+            <a:ext cx="350634" cy="510483"/>
           </a:xfrm>
           <a:prstGeom prst="rect">
             <a:avLst/>
@@ -16780,8 +17212,8 @@
         </p:nvSpPr>
         <p:spPr>
           <a:xfrm rot="0">
-            <a:off x="1219200" y="1104900"/>
-            <a:ext cx="16325088" cy="472383"/>
+            <a:off x="1219200" y="1066800"/>
+            <a:ext cx="16325088" cy="510483"/>
           </a:xfrm>
           <a:prstGeom prst="rect">
             <a:avLst/>
@@ -16821,8 +17253,8 @@
         </p:nvSpPr>
         <p:spPr>
           <a:xfrm rot="0">
-            <a:off x="1219200" y="2053533"/>
-            <a:ext cx="16325088" cy="834333"/>
+            <a:off x="1219200" y="2120208"/>
+            <a:ext cx="16325088" cy="767658"/>
           </a:xfrm>
           <a:prstGeom prst="rect">
             <a:avLst/>
@@ -16862,8 +17294,8 @@
         </p:nvSpPr>
         <p:spPr>
           <a:xfrm rot="0">
-            <a:off x="1219200" y="3068841"/>
-            <a:ext cx="16325088" cy="619125"/>
+            <a:off x="1219200" y="3040266"/>
+            <a:ext cx="16325088" cy="647700"/>
           </a:xfrm>
           <a:prstGeom prst="rect">
             <a:avLst/>
@@ -16902,9 +17334,9 @@
           <p:nvPr/>
         </p:nvSpPr>
         <p:spPr>
-          <a:xfrm rot="48900">
-            <a:off x="568242" y="8798300"/>
-            <a:ext cx="1340025" cy="0"/>
+          <a:xfrm rot="48180">
+            <a:off x="558651" y="8788775"/>
+            <a:ext cx="1359208" cy="0"/>
           </a:xfrm>
           <a:prstGeom prst="line">
             <a:avLst/>
@@ -16927,8 +17359,8 @@
         </p:nvSpPr>
         <p:spPr>
           <a:xfrm rot="0">
-            <a:off x="1485900" y="8119167"/>
-            <a:ext cx="16050387" cy="552450"/>
+            <a:off x="1485900" y="8081067"/>
+            <a:ext cx="16050387" cy="590550"/>
           </a:xfrm>
           <a:prstGeom prst="rect">
             <a:avLst/>
@@ -16968,8 +17400,8 @@
         </p:nvSpPr>
         <p:spPr>
           <a:xfrm rot="0">
-            <a:off x="1485900" y="8595417"/>
-            <a:ext cx="16050387" cy="864298"/>
+            <a:off x="1485900" y="8557317"/>
+            <a:ext cx="16050387" cy="621030"/>
           </a:xfrm>
           <a:prstGeom prst="rect">
             <a:avLst/>
@@ -16996,7 +17428,7 @@
                 <a:cs typeface="IBM Plex Sans"/>
                 <a:sym typeface="IBM Plex Sans"/>
               </a:rPr>
-              <a:t>anilamunir15@gmail.com · Choa Saidan Shah, Chakwal, Pakistan · 1 January – 1 February 2026</a:t>
+              <a:t>anilamunir15@gmail.com · Choa Saidan Shah, Chakwal, Pakistan · 1 January – 28  February 2026</a:t>
             </a:r>
           </a:p>
           <a:p>
@@ -17015,7 +17447,7 @@
                 <a:cs typeface="IBM Plex Sans"/>
                 <a:sym typeface="IBM Plex Sans"/>
               </a:rPr>
-              <a:t>Applicant, Master of Public Health (DAAD EPOS)</a:t>
+              <a:t>Applicant, Master of Health (DAAD EPOS)</a:t>
             </a:r>
           </a:p>
         </p:txBody>
@@ -17060,8 +17492,8 @@
         </p:nvSpPr>
         <p:spPr>
           <a:xfrm rot="0">
-            <a:off x="1219200" y="1104900"/>
-            <a:ext cx="16325088" cy="472383"/>
+            <a:off x="1219200" y="1066800"/>
+            <a:ext cx="16325088" cy="510483"/>
           </a:xfrm>
           <a:prstGeom prst="rect">
             <a:avLst/>
@@ -17101,8 +17533,8 @@
         </p:nvSpPr>
         <p:spPr>
           <a:xfrm rot="0">
-            <a:off x="1219200" y="1720158"/>
-            <a:ext cx="16325088" cy="672408"/>
+            <a:off x="1219200" y="1739208"/>
+            <a:ext cx="16325088" cy="653358"/>
           </a:xfrm>
           <a:prstGeom prst="rect">
             <a:avLst/>
@@ -17142,8 +17574,8 @@
         </p:nvSpPr>
         <p:spPr>
           <a:xfrm rot="4380">
-            <a:off x="1204912" y="3506991"/>
-            <a:ext cx="7496204" cy="0"/>
+            <a:off x="1200150" y="3502228"/>
+            <a:ext cx="7505738" cy="0"/>
           </a:xfrm>
           <a:prstGeom prst="line">
             <a:avLst/>
@@ -17166,8 +17598,8 @@
         </p:nvSpPr>
         <p:spPr>
           <a:xfrm rot="0">
-            <a:off x="1219200" y="2849766"/>
-            <a:ext cx="7691628" cy="552450"/>
+            <a:off x="1219200" y="2811666"/>
+            <a:ext cx="7691628" cy="590550"/>
           </a:xfrm>
           <a:prstGeom prst="rect">
             <a:avLst/>
@@ -17219,8 +17651,8 @@
         </p:nvSpPr>
         <p:spPr>
           <a:xfrm rot="4380">
-            <a:off x="1204912" y="4221366"/>
-            <a:ext cx="7496204" cy="0"/>
+            <a:off x="1200150" y="4216603"/>
+            <a:ext cx="7505738" cy="0"/>
           </a:xfrm>
           <a:prstGeom prst="line">
             <a:avLst/>
@@ -17243,8 +17675,8 @@
         </p:nvSpPr>
         <p:spPr>
           <a:xfrm rot="0">
-            <a:off x="1219200" y="3564141"/>
-            <a:ext cx="7691628" cy="552450"/>
+            <a:off x="1219200" y="3526041"/>
+            <a:ext cx="7691628" cy="590550"/>
           </a:xfrm>
           <a:prstGeom prst="rect">
             <a:avLst/>
@@ -17296,8 +17728,8 @@
         </p:nvSpPr>
         <p:spPr>
           <a:xfrm rot="4380">
-            <a:off x="1204912" y="4935741"/>
-            <a:ext cx="7496204" cy="0"/>
+            <a:off x="1200150" y="4930978"/>
+            <a:ext cx="7505738" cy="0"/>
           </a:xfrm>
           <a:prstGeom prst="line">
             <a:avLst/>
@@ -17320,8 +17752,8 @@
         </p:nvSpPr>
         <p:spPr>
           <a:xfrm rot="0">
-            <a:off x="1219200" y="4278516"/>
-            <a:ext cx="7691628" cy="552450"/>
+            <a:off x="1219200" y="4240416"/>
+            <a:ext cx="7691628" cy="590550"/>
           </a:xfrm>
           <a:prstGeom prst="rect">
             <a:avLst/>
@@ -17373,8 +17805,8 @@
         </p:nvSpPr>
         <p:spPr>
           <a:xfrm rot="4380">
-            <a:off x="1204912" y="5650116"/>
-            <a:ext cx="7496204" cy="0"/>
+            <a:off x="1200150" y="5645353"/>
+            <a:ext cx="7505738" cy="0"/>
           </a:xfrm>
           <a:prstGeom prst="line">
             <a:avLst/>
@@ -17397,8 +17829,8 @@
         </p:nvSpPr>
         <p:spPr>
           <a:xfrm rot="0">
-            <a:off x="1219200" y="4992891"/>
-            <a:ext cx="7691628" cy="552450"/>
+            <a:off x="1219200" y="4954791"/>
+            <a:ext cx="7691628" cy="590550"/>
           </a:xfrm>
           <a:prstGeom prst="rect">
             <a:avLst/>
@@ -17450,8 +17882,8 @@
         </p:nvSpPr>
         <p:spPr>
           <a:xfrm rot="4380">
-            <a:off x="1204912" y="6364491"/>
-            <a:ext cx="7496204" cy="0"/>
+            <a:off x="1200150" y="6359728"/>
+            <a:ext cx="7505738" cy="0"/>
           </a:xfrm>
           <a:prstGeom prst="line">
             <a:avLst/>
@@ -17474,8 +17906,8 @@
         </p:nvSpPr>
         <p:spPr>
           <a:xfrm rot="0">
-            <a:off x="1219200" y="5707266"/>
-            <a:ext cx="7691628" cy="552450"/>
+            <a:off x="1219200" y="5669166"/>
+            <a:ext cx="7691628" cy="590550"/>
           </a:xfrm>
           <a:prstGeom prst="rect">
             <a:avLst/>
@@ -17527,8 +17959,8 @@
         </p:nvSpPr>
         <p:spPr>
           <a:xfrm rot="4380">
-            <a:off x="1204912" y="7078866"/>
-            <a:ext cx="7496204" cy="0"/>
+            <a:off x="1200150" y="7074103"/>
+            <a:ext cx="7505738" cy="0"/>
           </a:xfrm>
           <a:prstGeom prst="line">
             <a:avLst/>
@@ -17551,8 +17983,8 @@
         </p:nvSpPr>
         <p:spPr>
           <a:xfrm rot="0">
-            <a:off x="1219200" y="6421641"/>
-            <a:ext cx="7691628" cy="552450"/>
+            <a:off x="1219200" y="6383541"/>
+            <a:ext cx="7691628" cy="590550"/>
           </a:xfrm>
           <a:prstGeom prst="rect">
             <a:avLst/>
@@ -17604,8 +18036,8 @@
         </p:nvSpPr>
         <p:spPr>
           <a:xfrm rot="4380">
-            <a:off x="1204912" y="7793241"/>
-            <a:ext cx="7496204" cy="0"/>
+            <a:off x="1200150" y="7788478"/>
+            <a:ext cx="7505738" cy="0"/>
           </a:xfrm>
           <a:prstGeom prst="line">
             <a:avLst/>
@@ -17628,8 +18060,8 @@
         </p:nvSpPr>
         <p:spPr>
           <a:xfrm rot="0">
-            <a:off x="1219200" y="7136016"/>
-            <a:ext cx="7691628" cy="552450"/>
+            <a:off x="1219200" y="7097916"/>
+            <a:ext cx="7691628" cy="590550"/>
           </a:xfrm>
           <a:prstGeom prst="rect">
             <a:avLst/>
@@ -17681,8 +18113,8 @@
         </p:nvSpPr>
         <p:spPr>
           <a:xfrm rot="4380">
-            <a:off x="9586912" y="3506991"/>
-            <a:ext cx="7496204" cy="0"/>
+            <a:off x="9582150" y="3502228"/>
+            <a:ext cx="7505738" cy="0"/>
           </a:xfrm>
           <a:prstGeom prst="line">
             <a:avLst/>
@@ -17705,8 +18137,8 @@
         </p:nvSpPr>
         <p:spPr>
           <a:xfrm rot="0">
-            <a:off x="9601200" y="2849766"/>
-            <a:ext cx="7691628" cy="552450"/>
+            <a:off x="9601200" y="2811666"/>
+            <a:ext cx="7691628" cy="590550"/>
           </a:xfrm>
           <a:prstGeom prst="rect">
             <a:avLst/>
@@ -17758,8 +18190,8 @@
         </p:nvSpPr>
         <p:spPr>
           <a:xfrm rot="4380">
-            <a:off x="9586912" y="4221366"/>
-            <a:ext cx="7496204" cy="0"/>
+            <a:off x="9582150" y="4216603"/>
+            <a:ext cx="7505738" cy="0"/>
           </a:xfrm>
           <a:prstGeom prst="line">
             <a:avLst/>
@@ -17782,8 +18214,8 @@
         </p:nvSpPr>
         <p:spPr>
           <a:xfrm rot="0">
-            <a:off x="9601200" y="3564141"/>
-            <a:ext cx="7691628" cy="552450"/>
+            <a:off x="9601200" y="3526041"/>
+            <a:ext cx="7691628" cy="590550"/>
           </a:xfrm>
           <a:prstGeom prst="rect">
             <a:avLst/>
@@ -17835,8 +18267,8 @@
         </p:nvSpPr>
         <p:spPr>
           <a:xfrm rot="4380">
-            <a:off x="9586912" y="4935741"/>
-            <a:ext cx="7496204" cy="0"/>
+            <a:off x="9582150" y="4930978"/>
+            <a:ext cx="7505738" cy="0"/>
           </a:xfrm>
           <a:prstGeom prst="line">
             <a:avLst/>
@@ -17859,8 +18291,8 @@
         </p:nvSpPr>
         <p:spPr>
           <a:xfrm rot="0">
-            <a:off x="9601200" y="4278516"/>
-            <a:ext cx="7691628" cy="552450"/>
+            <a:off x="9601200" y="4240416"/>
+            <a:ext cx="7691628" cy="590550"/>
           </a:xfrm>
           <a:prstGeom prst="rect">
             <a:avLst/>
@@ -17912,8 +18344,8 @@
         </p:nvSpPr>
         <p:spPr>
           <a:xfrm rot="4380">
-            <a:off x="9586912" y="5650116"/>
-            <a:ext cx="7496204" cy="0"/>
+            <a:off x="9582150" y="5645353"/>
+            <a:ext cx="7505738" cy="0"/>
           </a:xfrm>
           <a:prstGeom prst="line">
             <a:avLst/>
@@ -17936,8 +18368,8 @@
         </p:nvSpPr>
         <p:spPr>
           <a:xfrm rot="0">
-            <a:off x="9601200" y="4992891"/>
-            <a:ext cx="7691628" cy="552450"/>
+            <a:off x="9601200" y="4954791"/>
+            <a:ext cx="7691628" cy="371601"/>
           </a:xfrm>
           <a:prstGeom prst="rect">
             <a:avLst/>
@@ -17976,7 +18408,7 @@
                 <a:cs typeface="IBM Plex Sans"/>
                 <a:sym typeface="IBM Plex Sans"/>
               </a:rPr>
-              <a:t>   Expected outcomes</a:t>
+              <a:t>    Achieved  outcomes</a:t>
             </a:r>
           </a:p>
         </p:txBody>
@@ -17989,8 +18421,8 @@
         </p:nvSpPr>
         <p:spPr>
           <a:xfrm rot="4380">
-            <a:off x="9586912" y="6364491"/>
-            <a:ext cx="7496204" cy="0"/>
+            <a:off x="9582150" y="6359728"/>
+            <a:ext cx="7505738" cy="0"/>
           </a:xfrm>
           <a:prstGeom prst="line">
             <a:avLst/>
@@ -18013,8 +18445,8 @@
         </p:nvSpPr>
         <p:spPr>
           <a:xfrm rot="0">
-            <a:off x="9601200" y="5707266"/>
-            <a:ext cx="7691628" cy="552450"/>
+            <a:off x="9601200" y="5669166"/>
+            <a:ext cx="7691628" cy="590550"/>
           </a:xfrm>
           <a:prstGeom prst="rect">
             <a:avLst/>
@@ -18066,8 +18498,8 @@
         </p:nvSpPr>
         <p:spPr>
           <a:xfrm rot="4380">
-            <a:off x="9586912" y="7078866"/>
-            <a:ext cx="7496204" cy="0"/>
+            <a:off x="9582150" y="7074103"/>
+            <a:ext cx="7505738" cy="0"/>
           </a:xfrm>
           <a:prstGeom prst="line">
             <a:avLst/>
@@ -18090,8 +18522,8 @@
         </p:nvSpPr>
         <p:spPr>
           <a:xfrm rot="0">
-            <a:off x="9601200" y="6421641"/>
-            <a:ext cx="7691628" cy="552450"/>
+            <a:off x="9601200" y="6383541"/>
+            <a:ext cx="7691628" cy="590550"/>
           </a:xfrm>
           <a:prstGeom prst="rect">
             <a:avLst/>
@@ -18143,8 +18575,8 @@
         </p:nvSpPr>
         <p:spPr>
           <a:xfrm rot="0">
-            <a:off x="1219200" y="9241184"/>
-            <a:ext cx="8225857" cy="472383"/>
+            <a:off x="1219200" y="9203084"/>
+            <a:ext cx="8225857" cy="510483"/>
           </a:xfrm>
           <a:prstGeom prst="rect">
             <a:avLst/>
@@ -18184,8 +18616,8 @@
         </p:nvSpPr>
         <p:spPr>
           <a:xfrm rot="0">
-            <a:off x="16931583" y="9241184"/>
-            <a:ext cx="213417" cy="472383"/>
+            <a:off x="16931583" y="9203084"/>
+            <a:ext cx="213417" cy="510483"/>
           </a:xfrm>
           <a:prstGeom prst="rect">
             <a:avLst/>
@@ -18257,8 +18689,8 @@
         </p:nvSpPr>
         <p:spPr>
           <a:xfrm rot="0">
-            <a:off x="1219200" y="1104900"/>
-            <a:ext cx="16325088" cy="472383"/>
+            <a:off x="1219200" y="1066800"/>
+            <a:ext cx="16325088" cy="510483"/>
           </a:xfrm>
           <a:prstGeom prst="rect">
             <a:avLst/>
@@ -18298,8 +18730,8 @@
         </p:nvSpPr>
         <p:spPr>
           <a:xfrm rot="0">
-            <a:off x="1219200" y="1720158"/>
-            <a:ext cx="16325088" cy="672408"/>
+            <a:off x="1219200" y="1739208"/>
+            <a:ext cx="16325088" cy="653358"/>
           </a:xfrm>
           <a:prstGeom prst="rect">
             <a:avLst/>
@@ -18339,8 +18771,8 @@
         </p:nvSpPr>
         <p:spPr>
           <a:xfrm rot="0">
-            <a:off x="1219200" y="4387158"/>
-            <a:ext cx="7456170" cy="2724150"/>
+            <a:off x="1219200" y="4349058"/>
+            <a:ext cx="7456170" cy="2762250"/>
           </a:xfrm>
           <a:prstGeom prst="rect">
             <a:avLst/>
@@ -18379,9 +18811,9 @@
           <p:nvPr/>
         </p:nvSpPr>
         <p:spPr>
-          <a:xfrm rot="51420">
-            <a:off x="8754970" y="4181475"/>
-            <a:ext cx="1273350" cy="0"/>
+          <a:xfrm rot="50640">
+            <a:off x="8745379" y="4171950"/>
+            <a:ext cx="1292542" cy="0"/>
           </a:xfrm>
           <a:prstGeom prst="line">
             <a:avLst/>
@@ -18404,8 +18836,8 @@
         </p:nvSpPr>
         <p:spPr>
           <a:xfrm rot="0">
-            <a:off x="9715500" y="3497609"/>
-            <a:ext cx="7573899" cy="472383"/>
+            <a:off x="9715500" y="3459509"/>
+            <a:ext cx="7573899" cy="510483"/>
           </a:xfrm>
           <a:prstGeom prst="rect">
             <a:avLst/>
@@ -18445,8 +18877,8 @@
         </p:nvSpPr>
         <p:spPr>
           <a:xfrm rot="0">
-            <a:off x="9715500" y="3893791"/>
-            <a:ext cx="7573899" cy="952500"/>
+            <a:off x="9715500" y="3855691"/>
+            <a:ext cx="7573899" cy="990600"/>
           </a:xfrm>
           <a:prstGeom prst="rect">
             <a:avLst/>
@@ -18485,9 +18917,9 @@
           <p:nvPr/>
         </p:nvSpPr>
         <p:spPr>
-          <a:xfrm rot="51420">
-            <a:off x="8754970" y="5758758"/>
-            <a:ext cx="1273350" cy="0"/>
+          <a:xfrm rot="50640">
+            <a:off x="8745379" y="5749233"/>
+            <a:ext cx="1292542" cy="0"/>
           </a:xfrm>
           <a:prstGeom prst="line">
             <a:avLst/>
@@ -18510,8 +18942,8 @@
         </p:nvSpPr>
         <p:spPr>
           <a:xfrm rot="0">
-            <a:off x="9715500" y="5074891"/>
-            <a:ext cx="7573899" cy="472383"/>
+            <a:off x="9715500" y="5036791"/>
+            <a:ext cx="7573899" cy="510483"/>
           </a:xfrm>
           <a:prstGeom prst="rect">
             <a:avLst/>
@@ -18551,8 +18983,8 @@
         </p:nvSpPr>
         <p:spPr>
           <a:xfrm rot="0">
-            <a:off x="9715500" y="5471074"/>
-            <a:ext cx="7573899" cy="952500"/>
+            <a:off x="9715500" y="5432974"/>
+            <a:ext cx="7573899" cy="990600"/>
           </a:xfrm>
           <a:prstGeom prst="rect">
             <a:avLst/>
@@ -18591,9 +19023,9 @@
           <p:nvPr/>
         </p:nvSpPr>
         <p:spPr>
-          <a:xfrm rot="51420">
-            <a:off x="8754970" y="7336031"/>
-            <a:ext cx="1273350" cy="0"/>
+          <a:xfrm rot="50640">
+            <a:off x="8745379" y="7326506"/>
+            <a:ext cx="1292542" cy="0"/>
           </a:xfrm>
           <a:prstGeom prst="line">
             <a:avLst/>
@@ -18616,8 +19048,8 @@
         </p:nvSpPr>
         <p:spPr>
           <a:xfrm rot="0">
-            <a:off x="9715500" y="6652174"/>
-            <a:ext cx="7573899" cy="472383"/>
+            <a:off x="9715500" y="6614074"/>
+            <a:ext cx="7573899" cy="510483"/>
           </a:xfrm>
           <a:prstGeom prst="rect">
             <a:avLst/>
@@ -18657,8 +19089,8 @@
         </p:nvSpPr>
         <p:spPr>
           <a:xfrm rot="0">
-            <a:off x="9715500" y="7048348"/>
-            <a:ext cx="7573899" cy="952500"/>
+            <a:off x="9715500" y="7010248"/>
+            <a:ext cx="7573899" cy="990600"/>
           </a:xfrm>
           <a:prstGeom prst="rect">
             <a:avLst/>
@@ -18698,8 +19130,8 @@
         </p:nvSpPr>
         <p:spPr>
           <a:xfrm rot="0">
-            <a:off x="1219200" y="9241184"/>
-            <a:ext cx="8225857" cy="472383"/>
+            <a:off x="1219200" y="9203084"/>
+            <a:ext cx="8225857" cy="510483"/>
           </a:xfrm>
           <a:prstGeom prst="rect">
             <a:avLst/>
@@ -18739,8 +19171,8 @@
         </p:nvSpPr>
         <p:spPr>
           <a:xfrm rot="0">
-            <a:off x="16931583" y="9241184"/>
-            <a:ext cx="213417" cy="472383"/>
+            <a:off x="16931583" y="9203084"/>
+            <a:ext cx="213417" cy="510483"/>
           </a:xfrm>
           <a:prstGeom prst="rect">
             <a:avLst/>
@@ -18812,8 +19244,8 @@
         </p:nvSpPr>
         <p:spPr>
           <a:xfrm rot="0">
-            <a:off x="1219200" y="1104900"/>
-            <a:ext cx="16325088" cy="472383"/>
+            <a:off x="1219200" y="1066800"/>
+            <a:ext cx="16325088" cy="510483"/>
           </a:xfrm>
           <a:prstGeom prst="rect">
             <a:avLst/>
@@ -18853,8 +19285,8 @@
         </p:nvSpPr>
         <p:spPr>
           <a:xfrm rot="0">
-            <a:off x="1219200" y="1720158"/>
-            <a:ext cx="16325088" cy="672408"/>
+            <a:off x="1219200" y="1739208"/>
+            <a:ext cx="16325088" cy="653358"/>
           </a:xfrm>
           <a:prstGeom prst="rect">
             <a:avLst/>
@@ -18946,8 +19378,8 @@
         </p:nvSpPr>
         <p:spPr>
           <a:xfrm rot="0">
-            <a:off x="1545250" y="3554616"/>
-            <a:ext cx="4427868" cy="876300"/>
+            <a:off x="1545250" y="3783216"/>
+            <a:ext cx="4427868" cy="647700"/>
           </a:xfrm>
           <a:prstGeom prst="rect">
             <a:avLst/>
@@ -18987,8 +19419,8 @@
         </p:nvSpPr>
         <p:spPr>
           <a:xfrm rot="0">
-            <a:off x="1609725" y="4726191"/>
-            <a:ext cx="4427868" cy="552450"/>
+            <a:off x="1609725" y="4688091"/>
+            <a:ext cx="4427868" cy="590550"/>
           </a:xfrm>
           <a:prstGeom prst="rect">
             <a:avLst/>
@@ -19080,8 +19512,8 @@
         </p:nvSpPr>
         <p:spPr>
           <a:xfrm rot="0">
-            <a:off x="6603949" y="3554616"/>
-            <a:ext cx="4428020" cy="876300"/>
+            <a:off x="6603949" y="3783216"/>
+            <a:ext cx="4428020" cy="647700"/>
           </a:xfrm>
           <a:prstGeom prst="rect">
             <a:avLst/>
@@ -19121,8 +19553,8 @@
         </p:nvSpPr>
         <p:spPr>
           <a:xfrm rot="0">
-            <a:off x="6994474" y="4726191"/>
-            <a:ext cx="4428020" cy="552450"/>
+            <a:off x="6994474" y="4688091"/>
+            <a:ext cx="4428020" cy="590550"/>
           </a:xfrm>
           <a:prstGeom prst="rect">
             <a:avLst/>
@@ -19214,8 +19646,8 @@
         </p:nvSpPr>
         <p:spPr>
           <a:xfrm rot="0">
-            <a:off x="12358907" y="3497466"/>
-            <a:ext cx="4427868" cy="876300"/>
+            <a:off x="12358907" y="3726066"/>
+            <a:ext cx="4427868" cy="647700"/>
           </a:xfrm>
           <a:prstGeom prst="rect">
             <a:avLst/>
@@ -19255,8 +19687,8 @@
         </p:nvSpPr>
         <p:spPr>
           <a:xfrm rot="0">
-            <a:off x="12379376" y="4726191"/>
-            <a:ext cx="4427868" cy="552450"/>
+            <a:off x="12379376" y="4688091"/>
+            <a:ext cx="4427868" cy="590550"/>
           </a:xfrm>
           <a:prstGeom prst="rect">
             <a:avLst/>
@@ -19296,8 +19728,8 @@
         </p:nvSpPr>
         <p:spPr>
           <a:xfrm rot="0">
-            <a:off x="1219200" y="5630704"/>
-            <a:ext cx="5232349" cy="472383"/>
+            <a:off x="1219200" y="5592604"/>
+            <a:ext cx="5232349" cy="306705"/>
           </a:xfrm>
           <a:prstGeom prst="rect">
             <a:avLst/>
@@ -19324,7 +19756,7 @@
                 <a:cs typeface="IBM Plex Sans Bold"/>
                 <a:sym typeface="IBM Plex Sans Bold"/>
               </a:rPr>
-              <a:t>PARTICIPANTS</a:t>
+              <a:t>6</a:t>
             </a:r>
           </a:p>
         </p:txBody>
@@ -19337,8 +19769,8 @@
         </p:nvSpPr>
         <p:spPr>
           <a:xfrm rot="0">
-            <a:off x="1219200" y="6026696"/>
-            <a:ext cx="5232349" cy="952500"/>
+            <a:off x="1219200" y="5988596"/>
+            <a:ext cx="5232349" cy="990600"/>
           </a:xfrm>
           <a:prstGeom prst="rect">
             <a:avLst/>
@@ -19378,8 +19810,8 @@
         </p:nvSpPr>
         <p:spPr>
           <a:xfrm rot="0">
-            <a:off x="6603949" y="5630704"/>
-            <a:ext cx="5232502" cy="472383"/>
+            <a:off x="6603949" y="5592604"/>
+            <a:ext cx="5232502" cy="510483"/>
           </a:xfrm>
           <a:prstGeom prst="rect">
             <a:avLst/>
@@ -19419,8 +19851,8 @@
         </p:nvSpPr>
         <p:spPr>
           <a:xfrm rot="0">
-            <a:off x="6603949" y="6026696"/>
-            <a:ext cx="5232502" cy="952500"/>
+            <a:off x="6603949" y="5988596"/>
+            <a:ext cx="5232502" cy="990600"/>
           </a:xfrm>
           <a:prstGeom prst="rect">
             <a:avLst/>
@@ -19460,8 +19892,8 @@
         </p:nvSpPr>
         <p:spPr>
           <a:xfrm rot="0">
-            <a:off x="11988851" y="5630704"/>
-            <a:ext cx="5232349" cy="472383"/>
+            <a:off x="11988851" y="5592604"/>
+            <a:ext cx="5232349" cy="510483"/>
           </a:xfrm>
           <a:prstGeom prst="rect">
             <a:avLst/>
@@ -19501,8 +19933,8 @@
         </p:nvSpPr>
         <p:spPr>
           <a:xfrm rot="0">
-            <a:off x="11988851" y="6026696"/>
-            <a:ext cx="5232349" cy="952500"/>
+            <a:off x="11988851" y="5988596"/>
+            <a:ext cx="5232349" cy="990600"/>
           </a:xfrm>
           <a:prstGeom prst="rect">
             <a:avLst/>
@@ -19542,8 +19974,8 @@
         </p:nvSpPr>
         <p:spPr>
           <a:xfrm rot="0">
-            <a:off x="1219200" y="9241184"/>
-            <a:ext cx="8225857" cy="472383"/>
+            <a:off x="1219200" y="9203084"/>
+            <a:ext cx="8225857" cy="510483"/>
           </a:xfrm>
           <a:prstGeom prst="rect">
             <a:avLst/>
@@ -19583,8 +20015,8 @@
         </p:nvSpPr>
         <p:spPr>
           <a:xfrm rot="0">
-            <a:off x="16931583" y="9241184"/>
-            <a:ext cx="213417" cy="472383"/>
+            <a:off x="16931583" y="9203084"/>
+            <a:ext cx="213417" cy="510483"/>
           </a:xfrm>
           <a:prstGeom prst="rect">
             <a:avLst/>
@@ -19677,7 +20109,7 @@
         <p:spPr>
           <a:xfrm rot="0">
             <a:off x="1265234" y="7351033"/>
-            <a:ext cx="2897838" cy="1602924"/>
+            <a:ext cx="2897838" cy="1104900"/>
           </a:xfrm>
           <a:prstGeom prst="rect">
             <a:avLst/>
@@ -19742,7 +20174,7 @@
                 <a:cs typeface="IBM Plex Sans"/>
                 <a:sym typeface="IBM Plex Sans"/>
               </a:rPr>
-              <a:t>1–3 Jan 2026</a:t>
+              <a:t>1–3Jan 2026</a:t>
             </a:r>
           </a:p>
         </p:txBody>
@@ -19808,7 +20240,7 @@
         <p:spPr>
           <a:xfrm rot="0">
             <a:off x="4480150" y="7351033"/>
-            <a:ext cx="2897838" cy="1602924"/>
+            <a:ext cx="2897838" cy="800100"/>
           </a:xfrm>
           <a:prstGeom prst="rect">
             <a:avLst/>
@@ -19873,7 +20305,19 @@
                 <a:cs typeface="IBM Plex Sans"/>
                 <a:sym typeface="IBM Plex Sans"/>
               </a:rPr>
-              <a:t>18–19 Jan 2026</a:t>
+              <a:t>15</a:t>
+            </a:r>
+            <a:r>
+              <a:rPr lang="en-US" sz="1800" spc="178">
+                <a:solidFill>
+                  <a:srgbClr val="3F4B57"/>
+                </a:solidFill>
+                <a:latin typeface="IBM Plex Sans"/>
+                <a:ea typeface="IBM Plex Sans"/>
+                <a:cs typeface="IBM Plex Sans"/>
+                <a:sym typeface="IBM Plex Sans"/>
+              </a:rPr>
+              <a:t>–21 Jan 2026</a:t>
             </a:r>
           </a:p>
         </p:txBody>
@@ -19939,7 +20383,7 @@
         <p:spPr>
           <a:xfrm rot="0">
             <a:off x="7695076" y="7351033"/>
-            <a:ext cx="2897838" cy="1602924"/>
+            <a:ext cx="2897838" cy="1104900"/>
           </a:xfrm>
           <a:prstGeom prst="rect">
             <a:avLst/>
@@ -20004,7 +20448,19 @@
                 <a:cs typeface="IBM Plex Sans"/>
                 <a:sym typeface="IBM Plex Sans"/>
               </a:rPr>
-              <a:t>24–25 Jan 2026</a:t>
+              <a:t>22</a:t>
+            </a:r>
+            <a:r>
+              <a:rPr lang="en-US" sz="1800" spc="178">
+                <a:solidFill>
+                  <a:srgbClr val="3F4B57"/>
+                </a:solidFill>
+                <a:latin typeface="IBM Plex Sans"/>
+                <a:ea typeface="IBM Plex Sans"/>
+                <a:cs typeface="IBM Plex Sans"/>
+                <a:sym typeface="IBM Plex Sans"/>
+              </a:rPr>
+              <a:t>–28 Jan 2026</a:t>
             </a:r>
           </a:p>
         </p:txBody>
@@ -20070,7 +20526,7 @@
         <p:spPr>
           <a:xfrm rot="0">
             <a:off x="10909992" y="7351033"/>
-            <a:ext cx="2897838" cy="1602924"/>
+            <a:ext cx="2897838" cy="1104900"/>
           </a:xfrm>
           <a:prstGeom prst="rect">
             <a:avLst/>
@@ -20135,7 +20591,7 @@
                 <a:cs typeface="IBM Plex Sans"/>
                 <a:sym typeface="IBM Plex Sans"/>
               </a:rPr>
-              <a:t>28–29 Jan 2026</a:t>
+              <a:t>29Jan–04 Feb 2026</a:t>
             </a:r>
           </a:p>
         </p:txBody>
@@ -20266,7 +20722,7 @@
                 <a:cs typeface="IBM Plex Sans"/>
                 <a:sym typeface="IBM Plex Sans"/>
               </a:rPr>
-              <a:t>30Jan</a:t>
+              <a:t>05</a:t>
             </a:r>
             <a:r>
               <a:rPr lang="en-US" sz="1800" spc="178">
@@ -20278,7 +20734,7 @@
                 <a:cs typeface="IBM Plex Sans"/>
                 <a:sym typeface="IBM Plex Sans"/>
               </a:rPr>
-              <a:t>–01 Feb 2026</a:t>
+              <a:t>–11 Feb 2026</a:t>
             </a:r>
           </a:p>
         </p:txBody>
@@ -20323,8 +20779,8 @@
         </p:nvSpPr>
         <p:spPr>
           <a:xfrm rot="0">
-            <a:off x="1219200" y="1104900"/>
-            <a:ext cx="16325088" cy="472383"/>
+            <a:off x="1219200" y="1066800"/>
+            <a:ext cx="16325088" cy="510483"/>
           </a:xfrm>
           <a:prstGeom prst="rect">
             <a:avLst/>
@@ -20364,8 +20820,8 @@
         </p:nvSpPr>
         <p:spPr>
           <a:xfrm rot="0">
-            <a:off x="1219200" y="1720158"/>
-            <a:ext cx="16325088" cy="672408"/>
+            <a:off x="1219200" y="1739208"/>
+            <a:ext cx="16325088" cy="653358"/>
           </a:xfrm>
           <a:prstGeom prst="rect">
             <a:avLst/>
@@ -20457,8 +20913,8 @@
         </p:nvSpPr>
         <p:spPr>
           <a:xfrm rot="0">
-            <a:off x="1609725" y="3030741"/>
-            <a:ext cx="4427868" cy="742950"/>
+            <a:off x="1609725" y="2973591"/>
+            <a:ext cx="4427868" cy="800100"/>
           </a:xfrm>
           <a:prstGeom prst="rect">
             <a:avLst/>
@@ -20498,8 +20954,8 @@
         </p:nvSpPr>
         <p:spPr>
           <a:xfrm rot="0">
-            <a:off x="1609725" y="3735591"/>
-            <a:ext cx="4427868" cy="952500"/>
+            <a:off x="1609725" y="3697491"/>
+            <a:ext cx="4427868" cy="990600"/>
           </a:xfrm>
           <a:prstGeom prst="rect">
             <a:avLst/>
@@ -20591,8 +21047,8 @@
         </p:nvSpPr>
         <p:spPr>
           <a:xfrm rot="0">
-            <a:off x="6994474" y="3030741"/>
-            <a:ext cx="4427868" cy="742950"/>
+            <a:off x="6994474" y="2973591"/>
+            <a:ext cx="4427868" cy="800100"/>
           </a:xfrm>
           <a:prstGeom prst="rect">
             <a:avLst/>
@@ -20632,8 +21088,8 @@
         </p:nvSpPr>
         <p:spPr>
           <a:xfrm rot="0">
-            <a:off x="6994474" y="3735591"/>
-            <a:ext cx="4427868" cy="1352550"/>
+            <a:off x="6994474" y="3697491"/>
+            <a:ext cx="4427868" cy="1390650"/>
           </a:xfrm>
           <a:prstGeom prst="rect">
             <a:avLst/>
@@ -20725,8 +21181,8 @@
         </p:nvSpPr>
         <p:spPr>
           <a:xfrm rot="0">
-            <a:off x="12379223" y="3030741"/>
-            <a:ext cx="4427868" cy="742950"/>
+            <a:off x="12379223" y="2973591"/>
+            <a:ext cx="4427868" cy="800100"/>
           </a:xfrm>
           <a:prstGeom prst="rect">
             <a:avLst/>
@@ -20766,8 +21222,8 @@
         </p:nvSpPr>
         <p:spPr>
           <a:xfrm rot="0">
-            <a:off x="12379223" y="3735591"/>
-            <a:ext cx="4427868" cy="952500"/>
+            <a:off x="12379223" y="3697491"/>
+            <a:ext cx="4427868" cy="990600"/>
           </a:xfrm>
           <a:prstGeom prst="rect">
             <a:avLst/>
@@ -20859,8 +21315,8 @@
         </p:nvSpPr>
         <p:spPr>
           <a:xfrm rot="0">
-            <a:off x="1609725" y="5964441"/>
-            <a:ext cx="4427868" cy="742950"/>
+            <a:off x="1609725" y="5907291"/>
+            <a:ext cx="4427868" cy="800100"/>
           </a:xfrm>
           <a:prstGeom prst="rect">
             <a:avLst/>
@@ -20900,8 +21356,8 @@
         </p:nvSpPr>
         <p:spPr>
           <a:xfrm rot="0">
-            <a:off x="1609725" y="6669291"/>
-            <a:ext cx="4427868" cy="1352550"/>
+            <a:off x="1609725" y="6631191"/>
+            <a:ext cx="4427868" cy="1390650"/>
           </a:xfrm>
           <a:prstGeom prst="rect">
             <a:avLst/>
@@ -20993,8 +21449,8 @@
         </p:nvSpPr>
         <p:spPr>
           <a:xfrm rot="0">
-            <a:off x="6994474" y="5964441"/>
-            <a:ext cx="4427868" cy="742950"/>
+            <a:off x="6994474" y="5907291"/>
+            <a:ext cx="4427868" cy="800100"/>
           </a:xfrm>
           <a:prstGeom prst="rect">
             <a:avLst/>
@@ -21034,8 +21490,8 @@
         </p:nvSpPr>
         <p:spPr>
           <a:xfrm rot="0">
-            <a:off x="6994474" y="6669291"/>
-            <a:ext cx="4427868" cy="952500"/>
+            <a:off x="6994474" y="6631191"/>
+            <a:ext cx="4427868" cy="990600"/>
           </a:xfrm>
           <a:prstGeom prst="rect">
             <a:avLst/>
@@ -21127,8 +21583,8 @@
         </p:nvSpPr>
         <p:spPr>
           <a:xfrm rot="0">
-            <a:off x="12379223" y="5964441"/>
-            <a:ext cx="4427868" cy="742950"/>
+            <a:off x="12379223" y="5907291"/>
+            <a:ext cx="4427868" cy="800100"/>
           </a:xfrm>
           <a:prstGeom prst="rect">
             <a:avLst/>
@@ -21168,8 +21624,8 @@
         </p:nvSpPr>
         <p:spPr>
           <a:xfrm rot="0">
-            <a:off x="12379223" y="6669291"/>
-            <a:ext cx="4427868" cy="952500"/>
+            <a:off x="12379223" y="6631191"/>
+            <a:ext cx="4427868" cy="990600"/>
           </a:xfrm>
           <a:prstGeom prst="rect">
             <a:avLst/>
@@ -21209,8 +21665,8 @@
         </p:nvSpPr>
         <p:spPr>
           <a:xfrm rot="0">
-            <a:off x="1219200" y="9241184"/>
-            <a:ext cx="8225857" cy="472383"/>
+            <a:off x="1219200" y="9203084"/>
+            <a:ext cx="8225857" cy="510483"/>
           </a:xfrm>
           <a:prstGeom prst="rect">
             <a:avLst/>
@@ -21250,8 +21706,8 @@
         </p:nvSpPr>
         <p:spPr>
           <a:xfrm rot="0">
-            <a:off x="16931583" y="9241184"/>
-            <a:ext cx="213417" cy="472383"/>
+            <a:off x="16931583" y="9203084"/>
+            <a:ext cx="213417" cy="510483"/>
           </a:xfrm>
           <a:prstGeom prst="rect">
             <a:avLst/>
@@ -21323,8 +21779,8 @@
         </p:nvSpPr>
         <p:spPr>
           <a:xfrm rot="0">
-            <a:off x="1219200" y="1104900"/>
-            <a:ext cx="16325088" cy="472383"/>
+            <a:off x="1219200" y="1066800"/>
+            <a:ext cx="16325088" cy="510483"/>
           </a:xfrm>
           <a:prstGeom prst="rect">
             <a:avLst/>
@@ -21364,8 +21820,8 @@
         </p:nvSpPr>
         <p:spPr>
           <a:xfrm rot="0">
-            <a:off x="1219200" y="1720158"/>
-            <a:ext cx="16325088" cy="672408"/>
+            <a:off x="1219200" y="1739208"/>
+            <a:ext cx="16325088" cy="653358"/>
           </a:xfrm>
           <a:prstGeom prst="rect">
             <a:avLst/>
@@ -21407,15 +21863,15 @@
         </p:nvGraphicFramePr>
         <p:xfrm>
           <a:off x="1219200" y="2811662"/>
-          <a:ext cx="15811500" cy="5486400"/>
+          <a:ext cx="15798800" cy="5486400"/>
         </p:xfrm>
         <a:graphic>
           <a:graphicData uri="http://schemas.openxmlformats.org/drawingml/2006/table">
             <a:tbl>
               <a:tblPr/>
               <a:tblGrid>
-                <a:gridCol w="4465980"/>
-                <a:gridCol w="11345520"/>
+                <a:gridCol w="4473400"/>
+                <a:gridCol w="11325400"/>
               </a:tblGrid>
               <a:tr h="685800">
                 <a:tc>
@@ -22533,8 +22989,8 @@
         </p:nvSpPr>
         <p:spPr>
           <a:xfrm rot="0">
-            <a:off x="1219200" y="9241184"/>
-            <a:ext cx="8225857" cy="472383"/>
+            <a:off x="1219200" y="9203084"/>
+            <a:ext cx="8225857" cy="510483"/>
           </a:xfrm>
           <a:prstGeom prst="rect">
             <a:avLst/>
@@ -22574,8 +23030,8 @@
         </p:nvSpPr>
         <p:spPr>
           <a:xfrm rot="0">
-            <a:off x="16931583" y="9241184"/>
-            <a:ext cx="213417" cy="472383"/>
+            <a:off x="16931583" y="9203084"/>
+            <a:ext cx="213417" cy="510483"/>
           </a:xfrm>
           <a:prstGeom prst="rect">
             <a:avLst/>
@@ -22647,8 +23103,8 @@
         </p:nvSpPr>
         <p:spPr>
           <a:xfrm rot="0">
-            <a:off x="1219200" y="1104900"/>
-            <a:ext cx="16325088" cy="472383"/>
+            <a:off x="1219200" y="1066800"/>
+            <a:ext cx="16325088" cy="510483"/>
           </a:xfrm>
           <a:prstGeom prst="rect">
             <a:avLst/>
@@ -22688,8 +23144,8 @@
         </p:nvSpPr>
         <p:spPr>
           <a:xfrm rot="0">
-            <a:off x="1219200" y="1720158"/>
-            <a:ext cx="16325088" cy="672408"/>
+            <a:off x="1219200" y="1739208"/>
+            <a:ext cx="16325088" cy="653358"/>
           </a:xfrm>
           <a:prstGeom prst="rect">
             <a:avLst/>
@@ -22729,8 +23185,8 @@
         </p:nvSpPr>
         <p:spPr>
           <a:xfrm rot="0">
-            <a:off x="1219200" y="2640216"/>
-            <a:ext cx="647700" cy="742950"/>
+            <a:off x="1219200" y="2583066"/>
+            <a:ext cx="647700" cy="800100"/>
           </a:xfrm>
           <a:prstGeom prst="rect">
             <a:avLst/>
@@ -22770,8 +23226,8 @@
         </p:nvSpPr>
         <p:spPr>
           <a:xfrm rot="0">
-            <a:off x="2019300" y="2764041"/>
-            <a:ext cx="4798838" cy="552450"/>
+            <a:off x="2019300" y="2725941"/>
+            <a:ext cx="4798838" cy="590550"/>
           </a:xfrm>
           <a:prstGeom prst="rect">
             <a:avLst/>
@@ -22823,8 +23279,8 @@
         </p:nvSpPr>
         <p:spPr>
           <a:xfrm rot="0">
-            <a:off x="1219200" y="3249816"/>
-            <a:ext cx="647700" cy="742950"/>
+            <a:off x="1219200" y="3192666"/>
+            <a:ext cx="647700" cy="800100"/>
           </a:xfrm>
           <a:prstGeom prst="rect">
             <a:avLst/>
@@ -22864,8 +23320,8 @@
         </p:nvSpPr>
         <p:spPr>
           <a:xfrm rot="0">
-            <a:off x="2019300" y="3373641"/>
-            <a:ext cx="7394391" cy="552450"/>
+            <a:off x="2019300" y="3335541"/>
+            <a:ext cx="7394391" cy="590550"/>
           </a:xfrm>
           <a:prstGeom prst="rect">
             <a:avLst/>
@@ -22917,8 +23373,8 @@
         </p:nvSpPr>
         <p:spPr>
           <a:xfrm rot="0">
-            <a:off x="1219200" y="3859416"/>
-            <a:ext cx="647700" cy="742950"/>
+            <a:off x="1219200" y="3802266"/>
+            <a:ext cx="647700" cy="800100"/>
           </a:xfrm>
           <a:prstGeom prst="rect">
             <a:avLst/>
@@ -22958,8 +23414,8 @@
         </p:nvSpPr>
         <p:spPr>
           <a:xfrm rot="0">
-            <a:off x="2019300" y="3983241"/>
-            <a:ext cx="3733295" cy="552450"/>
+            <a:off x="2019300" y="3945141"/>
+            <a:ext cx="3733295" cy="590550"/>
           </a:xfrm>
           <a:prstGeom prst="rect">
             <a:avLst/>
@@ -23011,8 +23467,8 @@
         </p:nvSpPr>
         <p:spPr>
           <a:xfrm rot="0">
-            <a:off x="1219200" y="4469016"/>
-            <a:ext cx="647700" cy="742950"/>
+            <a:off x="1219200" y="4411866"/>
+            <a:ext cx="647700" cy="800100"/>
           </a:xfrm>
           <a:prstGeom prst="rect">
             <a:avLst/>
@@ -23052,8 +23508,8 @@
         </p:nvSpPr>
         <p:spPr>
           <a:xfrm rot="0">
-            <a:off x="2019300" y="4592841"/>
-            <a:ext cx="4551883" cy="552450"/>
+            <a:off x="2019300" y="4554741"/>
+            <a:ext cx="4551883" cy="590550"/>
           </a:xfrm>
           <a:prstGeom prst="rect">
             <a:avLst/>
@@ -23105,8 +23561,8 @@
         </p:nvSpPr>
         <p:spPr>
           <a:xfrm rot="0">
-            <a:off x="1219200" y="5078616"/>
-            <a:ext cx="647700" cy="742950"/>
+            <a:off x="1219200" y="5021466"/>
+            <a:ext cx="647700" cy="800100"/>
           </a:xfrm>
           <a:prstGeom prst="rect">
             <a:avLst/>
@@ -23146,8 +23602,8 @@
         </p:nvSpPr>
         <p:spPr>
           <a:xfrm rot="0">
-            <a:off x="2019300" y="5202441"/>
-            <a:ext cx="5572811" cy="552450"/>
+            <a:off x="2019300" y="5164341"/>
+            <a:ext cx="5572811" cy="590550"/>
           </a:xfrm>
           <a:prstGeom prst="rect">
             <a:avLst/>
@@ -23251,8 +23707,8 @@
         </p:nvSpPr>
         <p:spPr>
           <a:xfrm rot="0">
-            <a:off x="1571625" y="6250191"/>
-            <a:ext cx="10732960" cy="472383"/>
+            <a:off x="1571625" y="6212091"/>
+            <a:ext cx="10732960" cy="510483"/>
           </a:xfrm>
           <a:prstGeom prst="rect">
             <a:avLst/>
@@ -23292,8 +23748,8 @@
         </p:nvSpPr>
         <p:spPr>
           <a:xfrm rot="0">
-            <a:off x="1571625" y="6646364"/>
-            <a:ext cx="10732960" cy="952500"/>
+            <a:off x="1571625" y="6608264"/>
+            <a:ext cx="10732960" cy="990600"/>
           </a:xfrm>
           <a:prstGeom prst="rect">
             <a:avLst/>
@@ -23380,7 +23836,7 @@
             <a:blipFill>
               <a:blip r:embed="rId5"/>
               <a:stretch>
-                <a:fillRect l="-66261" t="0" r="-66261" b="0"/>
+                <a:fillRect l="-66304" t="0" r="-66304" b="0"/>
               </a:stretch>
             </a:blipFill>
           </p:spPr>
@@ -23394,8 +23850,8 @@
         </p:nvSpPr>
         <p:spPr>
           <a:xfrm rot="0">
-            <a:off x="1219200" y="9241184"/>
-            <a:ext cx="8225857" cy="472383"/>
+            <a:off x="1219200" y="9203084"/>
+            <a:ext cx="8225857" cy="510483"/>
           </a:xfrm>
           <a:prstGeom prst="rect">
             <a:avLst/>
@@ -23435,8 +23891,8 @@
         </p:nvSpPr>
         <p:spPr>
           <a:xfrm rot="0">
-            <a:off x="16931583" y="9241184"/>
-            <a:ext cx="213417" cy="472383"/>
+            <a:off x="16931583" y="9203084"/>
+            <a:ext cx="213417" cy="510483"/>
           </a:xfrm>
           <a:prstGeom prst="rect">
             <a:avLst/>
@@ -23508,8 +23964,8 @@
         </p:nvSpPr>
         <p:spPr>
           <a:xfrm rot="0">
-            <a:off x="1219200" y="1104900"/>
-            <a:ext cx="16325088" cy="472383"/>
+            <a:off x="1219200" y="1066800"/>
+            <a:ext cx="16325088" cy="510483"/>
           </a:xfrm>
           <a:prstGeom prst="rect">
             <a:avLst/>
@@ -23549,8 +24005,8 @@
         </p:nvSpPr>
         <p:spPr>
           <a:xfrm rot="0">
-            <a:off x="1219200" y="1720158"/>
-            <a:ext cx="16325088" cy="672408"/>
+            <a:off x="1219200" y="1739208"/>
+            <a:ext cx="16325088" cy="653358"/>
           </a:xfrm>
           <a:prstGeom prst="rect">
             <a:avLst/>
@@ -23683,8 +24139,8 @@
         </p:nvSpPr>
         <p:spPr>
           <a:xfrm rot="7560">
-            <a:off x="1595409" y="3802266"/>
-            <a:ext cx="4327503" cy="0"/>
+            <a:off x="1590637" y="3797503"/>
+            <a:ext cx="4337037" cy="0"/>
           </a:xfrm>
           <a:prstGeom prst="line">
             <a:avLst/>
@@ -23707,8 +24163,8 @@
         </p:nvSpPr>
         <p:spPr>
           <a:xfrm rot="0">
-            <a:off x="1609725" y="3859416"/>
-            <a:ext cx="4427868" cy="952500"/>
+            <a:off x="1609725" y="3821316"/>
+            <a:ext cx="4427868" cy="990600"/>
           </a:xfrm>
           <a:prstGeom prst="rect">
             <a:avLst/>
@@ -23748,8 +24204,8 @@
         </p:nvSpPr>
         <p:spPr>
           <a:xfrm rot="7560">
-            <a:off x="1595409" y="4916691"/>
-            <a:ext cx="4327503" cy="0"/>
+            <a:off x="1590637" y="4911928"/>
+            <a:ext cx="4337037" cy="0"/>
           </a:xfrm>
           <a:prstGeom prst="line">
             <a:avLst/>
@@ -23772,8 +24228,8 @@
         </p:nvSpPr>
         <p:spPr>
           <a:xfrm rot="0">
-            <a:off x="1609725" y="4973841"/>
-            <a:ext cx="4427868" cy="952500"/>
+            <a:off x="1609725" y="4935741"/>
+            <a:ext cx="4427868" cy="990600"/>
           </a:xfrm>
           <a:prstGeom prst="rect">
             <a:avLst/>
@@ -23813,8 +24269,8 @@
         </p:nvSpPr>
         <p:spPr>
           <a:xfrm rot="7560">
-            <a:off x="1595409" y="6031116"/>
-            <a:ext cx="4327503" cy="0"/>
+            <a:off x="1590637" y="6026353"/>
+            <a:ext cx="4337037" cy="0"/>
           </a:xfrm>
           <a:prstGeom prst="line">
             <a:avLst/>
@@ -23837,8 +24293,8 @@
         </p:nvSpPr>
         <p:spPr>
           <a:xfrm rot="0">
-            <a:off x="1609725" y="6088266"/>
-            <a:ext cx="4427868" cy="952500"/>
+            <a:off x="1609725" y="6050166"/>
+            <a:ext cx="4427868" cy="990600"/>
           </a:xfrm>
           <a:prstGeom prst="rect">
             <a:avLst/>
@@ -23971,8 +24427,8 @@
         </p:nvSpPr>
         <p:spPr>
           <a:xfrm rot="7560">
-            <a:off x="6980168" y="3802266"/>
-            <a:ext cx="4327655" cy="0"/>
+            <a:off x="6975396" y="3797503"/>
+            <a:ext cx="4337190" cy="0"/>
           </a:xfrm>
           <a:prstGeom prst="line">
             <a:avLst/>
@@ -23995,8 +24451,8 @@
         </p:nvSpPr>
         <p:spPr>
           <a:xfrm rot="0">
-            <a:off x="6994474" y="3859416"/>
-            <a:ext cx="4428020" cy="952500"/>
+            <a:off x="6994474" y="3821316"/>
+            <a:ext cx="4428020" cy="990600"/>
           </a:xfrm>
           <a:prstGeom prst="rect">
             <a:avLst/>
@@ -24036,8 +24492,8 @@
         </p:nvSpPr>
         <p:spPr>
           <a:xfrm rot="7560">
-            <a:off x="6980168" y="4916691"/>
-            <a:ext cx="4327655" cy="0"/>
+            <a:off x="6975396" y="4911928"/>
+            <a:ext cx="4337190" cy="0"/>
           </a:xfrm>
           <a:prstGeom prst="line">
             <a:avLst/>
@@ -24060,8 +24516,8 @@
         </p:nvSpPr>
         <p:spPr>
           <a:xfrm rot="0">
-            <a:off x="6994474" y="4973841"/>
-            <a:ext cx="4428020" cy="952500"/>
+            <a:off x="6994474" y="4935741"/>
+            <a:ext cx="4428020" cy="990600"/>
           </a:xfrm>
           <a:prstGeom prst="rect">
             <a:avLst/>
@@ -24194,8 +24650,8 @@
         </p:nvSpPr>
         <p:spPr>
           <a:xfrm rot="7560">
-            <a:off x="12365060" y="3802266"/>
-            <a:ext cx="4327503" cy="0"/>
+            <a:off x="12360288" y="3797503"/>
+            <a:ext cx="4337037" cy="0"/>
           </a:xfrm>
           <a:prstGeom prst="line">
             <a:avLst/>
@@ -24218,8 +24674,8 @@
         </p:nvSpPr>
         <p:spPr>
           <a:xfrm rot="0">
-            <a:off x="12379376" y="3859416"/>
-            <a:ext cx="4427868" cy="952500"/>
+            <a:off x="12379376" y="3821316"/>
+            <a:ext cx="4427868" cy="990600"/>
           </a:xfrm>
           <a:prstGeom prst="rect">
             <a:avLst/>
@@ -24259,8 +24715,8 @@
         </p:nvSpPr>
         <p:spPr>
           <a:xfrm rot="7560">
-            <a:off x="12365060" y="4916691"/>
-            <a:ext cx="4327503" cy="0"/>
+            <a:off x="12360288" y="4911928"/>
+            <a:ext cx="4337037" cy="0"/>
           </a:xfrm>
           <a:prstGeom prst="line">
             <a:avLst/>
@@ -24283,8 +24739,8 @@
         </p:nvSpPr>
         <p:spPr>
           <a:xfrm rot="0">
-            <a:off x="12379376" y="4973841"/>
-            <a:ext cx="4427868" cy="952500"/>
+            <a:off x="12379376" y="4935741"/>
+            <a:ext cx="4427868" cy="990600"/>
           </a:xfrm>
           <a:prstGeom prst="rect">
             <a:avLst/>
@@ -24324,8 +24780,8 @@
         </p:nvSpPr>
         <p:spPr>
           <a:xfrm rot="0">
-            <a:off x="1219200" y="9241184"/>
-            <a:ext cx="8225857" cy="472383"/>
+            <a:off x="1219200" y="9203084"/>
+            <a:ext cx="8225857" cy="510483"/>
           </a:xfrm>
           <a:prstGeom prst="rect">
             <a:avLst/>
@@ -24365,8 +24821,8 @@
         </p:nvSpPr>
         <p:spPr>
           <a:xfrm rot="0">
-            <a:off x="16931583" y="9241184"/>
-            <a:ext cx="213417" cy="472383"/>
+            <a:off x="16931583" y="9203084"/>
+            <a:ext cx="213417" cy="510483"/>
           </a:xfrm>
           <a:prstGeom prst="rect">
             <a:avLst/>
@@ -24438,8 +24894,8 @@
         </p:nvSpPr>
         <p:spPr>
           <a:xfrm rot="0">
-            <a:off x="1219200" y="1104900"/>
-            <a:ext cx="16325088" cy="472383"/>
+            <a:off x="1219200" y="1066800"/>
+            <a:ext cx="16325088" cy="510483"/>
           </a:xfrm>
           <a:prstGeom prst="rect">
             <a:avLst/>
@@ -24479,8 +24935,8 @@
         </p:nvSpPr>
         <p:spPr>
           <a:xfrm rot="0">
-            <a:off x="1219200" y="1720158"/>
-            <a:ext cx="16325088" cy="672408"/>
+            <a:off x="1219200" y="1739208"/>
+            <a:ext cx="16325088" cy="653358"/>
           </a:xfrm>
           <a:prstGeom prst="rect">
             <a:avLst/>
@@ -24613,8 +25069,8 @@
         </p:nvSpPr>
         <p:spPr>
           <a:xfrm rot="7560">
-            <a:off x="1595409" y="3802266"/>
-            <a:ext cx="4327503" cy="0"/>
+            <a:off x="1590637" y="3797503"/>
+            <a:ext cx="4337037" cy="0"/>
           </a:xfrm>
           <a:prstGeom prst="line">
             <a:avLst/>
@@ -24637,8 +25093,8 @@
         </p:nvSpPr>
         <p:spPr>
           <a:xfrm rot="0">
-            <a:off x="1609725" y="3859416"/>
-            <a:ext cx="4427868" cy="952500"/>
+            <a:off x="1609725" y="3821316"/>
+            <a:ext cx="4427868" cy="990600"/>
           </a:xfrm>
           <a:prstGeom prst="rect">
             <a:avLst/>
@@ -24678,8 +25134,8 @@
         </p:nvSpPr>
         <p:spPr>
           <a:xfrm rot="7560">
-            <a:off x="1595409" y="4916691"/>
-            <a:ext cx="4327503" cy="0"/>
+            <a:off x="1590637" y="4911928"/>
+            <a:ext cx="4337037" cy="0"/>
           </a:xfrm>
           <a:prstGeom prst="line">
             <a:avLst/>
@@ -24702,8 +25158,8 @@
         </p:nvSpPr>
         <p:spPr>
           <a:xfrm rot="0">
-            <a:off x="1609725" y="4973841"/>
-            <a:ext cx="4427868" cy="952500"/>
+            <a:off x="1609725" y="4935741"/>
+            <a:ext cx="4427868" cy="990600"/>
           </a:xfrm>
           <a:prstGeom prst="rect">
             <a:avLst/>
@@ -24836,8 +25292,8 @@
         </p:nvSpPr>
         <p:spPr>
           <a:xfrm rot="7560">
-            <a:off x="6980168" y="3802266"/>
-            <a:ext cx="4327655" cy="0"/>
+            <a:off x="6975396" y="3797503"/>
+            <a:ext cx="4337190" cy="0"/>
           </a:xfrm>
           <a:prstGeom prst="line">
             <a:avLst/>
@@ -24860,8 +25316,8 @@
         </p:nvSpPr>
         <p:spPr>
           <a:xfrm rot="0">
-            <a:off x="6994474" y="3859416"/>
-            <a:ext cx="4428020" cy="552450"/>
+            <a:off x="6994474" y="3821316"/>
+            <a:ext cx="4428020" cy="590550"/>
           </a:xfrm>
           <a:prstGeom prst="rect">
             <a:avLst/>
@@ -24901,8 +25357,8 @@
         </p:nvSpPr>
         <p:spPr>
           <a:xfrm rot="7560">
-            <a:off x="6980168" y="4516641"/>
-            <a:ext cx="4327655" cy="0"/>
+            <a:off x="6975396" y="4511878"/>
+            <a:ext cx="4337190" cy="0"/>
           </a:xfrm>
           <a:prstGeom prst="line">
             <a:avLst/>
@@ -24925,8 +25381,8 @@
         </p:nvSpPr>
         <p:spPr>
           <a:xfrm rot="0">
-            <a:off x="6994474" y="4573791"/>
-            <a:ext cx="4428020" cy="952500"/>
+            <a:off x="6994474" y="4535691"/>
+            <a:ext cx="4428020" cy="990600"/>
           </a:xfrm>
           <a:prstGeom prst="rect">
             <a:avLst/>
@@ -24966,8 +25422,8 @@
         </p:nvSpPr>
         <p:spPr>
           <a:xfrm rot="7560">
-            <a:off x="6980168" y="5631066"/>
-            <a:ext cx="4327655" cy="0"/>
+            <a:off x="6975396" y="5626303"/>
+            <a:ext cx="4337190" cy="0"/>
           </a:xfrm>
           <a:prstGeom prst="line">
             <a:avLst/>
@@ -24990,8 +25446,8 @@
         </p:nvSpPr>
         <p:spPr>
           <a:xfrm rot="0">
-            <a:off x="6994474" y="5688216"/>
-            <a:ext cx="4428020" cy="952500"/>
+            <a:off x="6994474" y="5650116"/>
+            <a:ext cx="4428020" cy="990600"/>
           </a:xfrm>
           <a:prstGeom prst="rect">
             <a:avLst/>
@@ -25124,8 +25580,8 @@
         </p:nvSpPr>
         <p:spPr>
           <a:xfrm rot="7560">
-            <a:off x="12365060" y="3802266"/>
-            <a:ext cx="4327503" cy="0"/>
+            <a:off x="12360288" y="3797503"/>
+            <a:ext cx="4337037" cy="0"/>
           </a:xfrm>
           <a:prstGeom prst="line">
             <a:avLst/>
@@ -25148,8 +25604,8 @@
         </p:nvSpPr>
         <p:spPr>
           <a:xfrm rot="0">
-            <a:off x="12379376" y="3859416"/>
-            <a:ext cx="4427868" cy="1352550"/>
+            <a:off x="12379376" y="3821316"/>
+            <a:ext cx="4427868" cy="1390650"/>
           </a:xfrm>
           <a:prstGeom prst="rect">
             <a:avLst/>
@@ -25189,8 +25645,8 @@
         </p:nvSpPr>
         <p:spPr>
           <a:xfrm rot="0">
-            <a:off x="1219200" y="9241184"/>
-            <a:ext cx="8225857" cy="472383"/>
+            <a:off x="1219200" y="9203084"/>
+            <a:ext cx="8225857" cy="510483"/>
           </a:xfrm>
           <a:prstGeom prst="rect">
             <a:avLst/>
@@ -25230,8 +25686,8 @@
         </p:nvSpPr>
         <p:spPr>
           <a:xfrm rot="0">
-            <a:off x="16931583" y="9241184"/>
-            <a:ext cx="213417" cy="472383"/>
+            <a:off x="16931583" y="9203084"/>
+            <a:ext cx="213417" cy="510483"/>
           </a:xfrm>
           <a:prstGeom prst="rect">
             <a:avLst/>

</xml_diff>